<commit_message>
added lecture9 with partial LaTeX equations
</commit_message>
<xml_diff>
--- a/python/CourseDesign/Week05e/Week5_Lecture9_Time_Frequency_Responses_Group_Delay.pptx
+++ b/python/CourseDesign/Week05e/Week5_Lecture9_Time_Frequency_Responses_Group_Delay.pptx
@@ -3410,7 +3410,7 @@
         <p:spPr>
           <a:xfrm>
             <a:off x="685800" y="1143000"/>
-            <a:ext cx="5486040" cy="3085920"/>
+            <a:ext cx="5486400" cy="3086100"/>
           </a:xfrm>
           <a:prstGeom prst="rect">
             <a:avLst/>
@@ -3575,7 +3575,7 @@
         <p:spPr>
           <a:xfrm>
             <a:off x="685800" y="1143000"/>
-            <a:ext cx="5486040" cy="3085920"/>
+            <a:ext cx="5486400" cy="3086100"/>
           </a:xfrm>
           <a:prstGeom prst="rect">
             <a:avLst/>
@@ -3740,7 +3740,7 @@
         <p:spPr>
           <a:xfrm>
             <a:off x="685800" y="1143000"/>
-            <a:ext cx="5486040" cy="3085920"/>
+            <a:ext cx="5486400" cy="3086100"/>
           </a:xfrm>
           <a:prstGeom prst="rect">
             <a:avLst/>
@@ -3905,7 +3905,7 @@
         <p:spPr>
           <a:xfrm>
             <a:off x="685800" y="1143000"/>
-            <a:ext cx="5486040" cy="3085920"/>
+            <a:ext cx="5486400" cy="3086100"/>
           </a:xfrm>
           <a:prstGeom prst="rect">
             <a:avLst/>
@@ -4070,7 +4070,7 @@
         <p:spPr>
           <a:xfrm>
             <a:off x="685800" y="1143000"/>
-            <a:ext cx="5486040" cy="3085920"/>
+            <a:ext cx="5486400" cy="3086100"/>
           </a:xfrm>
           <a:prstGeom prst="rect">
             <a:avLst/>
@@ -4235,7 +4235,7 @@
         <p:spPr>
           <a:xfrm>
             <a:off x="685800" y="1143000"/>
-            <a:ext cx="5486040" cy="3085920"/>
+            <a:ext cx="5486400" cy="3086100"/>
           </a:xfrm>
           <a:prstGeom prst="rect">
             <a:avLst/>
@@ -14829,178 +14829,596 @@
           </a:p>
         </p:txBody>
       </p:sp>
-      <p:sp>
-        <p:nvSpPr>
-          <p:cNvPr id="25" name="Text 5"/>
-          <p:cNvSpPr/>
-          <p:nvPr/>
-        </p:nvSpPr>
-        <p:spPr>
-          <a:xfrm>
-            <a:off x="822960" y="1554480"/>
-            <a:ext cx="10515240" cy="731160"/>
-          </a:xfrm>
-          <a:prstGeom prst="rect">
-            <a:avLst/>
-          </a:prstGeom>
-          <a:solidFill>
-            <a:srgbClr val="F4F7FB"/>
-          </a:solidFill>
-          <a:ln w="12700">
-            <a:solidFill>
-              <a:srgbClr val="D7E0EA"/>
-            </a:solidFill>
-            <a:round/>
-          </a:ln>
-        </p:spPr>
-        <p:style>
-          <a:lnRef idx="0">
-            <a:scrgbClr r="0" g="0" b="0"/>
-          </a:lnRef>
-          <a:fillRef idx="0">
-            <a:scrgbClr r="0" g="0" b="0"/>
-          </a:fillRef>
-          <a:effectRef idx="0">
-            <a:scrgbClr r="0" g="0" b="0"/>
-          </a:effectRef>
-          <a:fontRef idx="minor"/>
-        </p:style>
-        <p:txBody>
-          <a:bodyPr lIns="360" tIns="360" rIns="360" bIns="360" anchor="ctr">
-            <a:noAutofit/>
-          </a:bodyPr>
-          <a:lstStyle/>
-          <a:p>
-            <a:pPr algn="ctr" defTabSz="914400">
-              <a:lnSpc>
-                <a:spcPct val="100000"/>
-              </a:lnSpc>
-              <a:tabLst>
-                <a:tab pos="0" algn="l"/>
-              </a:tabLst>
-            </a:pPr>
-            <a:r>
-              <a:rPr lang="en-US" sz="2400" b="1" u="none" strike="noStrike">
-                <a:solidFill>
-                  <a:srgbClr val="17365D"/>
-                </a:solidFill>
-                <a:effectLst/>
-                <a:uFillTx/>
-                <a:latin typeface="Aptos"/>
-              </a:rPr>
-              <a:t>$$H(e^{j\omega})=H(z)\big|_{z=e^{j\omega}}$$</a:t>
-            </a:r>
-            <a:endParaRPr lang="en-US" sz="2400" b="0" u="none" strike="noStrike">
-              <a:solidFill>
-                <a:srgbClr val="000000"/>
-              </a:solidFill>
-              <a:effectLst/>
-              <a:uFillTx/>
-              <a:latin typeface="Arial"/>
-            </a:endParaRPr>
-          </a:p>
-        </p:txBody>
-      </p:sp>
-      <p:sp>
-        <p:nvSpPr>
-          <p:cNvPr id="26" name="Text 6"/>
-          <p:cNvSpPr/>
-          <p:nvPr/>
-        </p:nvSpPr>
-        <p:spPr>
-          <a:xfrm>
-            <a:off x="822960" y="2560320"/>
-            <a:ext cx="10423800" cy="2194200"/>
-          </a:xfrm>
-          <a:prstGeom prst="rect">
-            <a:avLst/>
-          </a:prstGeom>
-          <a:noFill/>
-          <a:ln w="0">
-            <a:noFill/>
-          </a:ln>
-        </p:spPr>
-        <p:style>
-          <a:lnRef idx="0">
-            <a:scrgbClr r="0" g="0" b="0"/>
-          </a:lnRef>
-          <a:fillRef idx="0">
-            <a:scrgbClr r="0" g="0" b="0"/>
-          </a:fillRef>
-          <a:effectRef idx="0">
-            <a:scrgbClr r="0" g="0" b="0"/>
-          </a:effectRef>
-          <a:fontRef idx="minor"/>
-        </p:style>
-        <p:txBody>
-          <a:bodyPr lIns="720" tIns="720" rIns="720" bIns="720" anchor="t">
-            <a:noAutofit/>
-          </a:bodyPr>
-          <a:lstStyle/>
-          <a:p>
-            <a:pPr marL="228600" indent="-228600" defTabSz="914400">
-              <a:lnSpc>
-                <a:spcPct val="100000"/>
-              </a:lnSpc>
-              <a:buClr>
-                <a:srgbClr val="1F2937"/>
-              </a:buClr>
-              <a:buFont typeface="Symbol" charset="2"/>
-              <a:buChar char=""/>
-            </a:pPr>
-            <a:r>
-              <a:rPr lang="en-US" sz="1800" b="0" u="none" strike="noStrike">
-                <a:solidFill>
-                  <a:srgbClr val="1F2937"/>
-                </a:solidFill>
-                <a:effectLst/>
-                <a:uFillTx/>
-                <a:latin typeface="Aptos"/>
-              </a:rPr>
-              <a:t>Every digital frequency $\omega$ corresponds to one point $e^{j\omega}$ on the unit circle.</a:t>
-            </a:r>
-            <a:endParaRPr lang="en-US" sz="1800" b="0" u="none" strike="noStrike">
-              <a:solidFill>
-                <a:srgbClr val="000000"/>
-              </a:solidFill>
-              <a:effectLst/>
-              <a:uFillTx/>
-              <a:latin typeface="Arial"/>
-            </a:endParaRPr>
-          </a:p>
-          <a:p>
-            <a:pPr marL="228600" indent="-228600" defTabSz="914400">
-              <a:lnSpc>
-                <a:spcPct val="100000"/>
-              </a:lnSpc>
-              <a:buClr>
-                <a:srgbClr val="1F2937"/>
-              </a:buClr>
-              <a:buFont typeface="Symbol" charset="2"/>
-              <a:buChar char=""/>
-            </a:pPr>
-            <a:r>
-              <a:rPr lang="en-US" sz="1800" b="0" u="none" strike="noStrike">
-                <a:solidFill>
-                  <a:srgbClr val="1F2937"/>
-                </a:solidFill>
-                <a:effectLst/>
-                <a:uFillTx/>
-                <a:latin typeface="Aptos"/>
-              </a:rPr>
-              <a:t>Magnitude and phase can be read geometrically from vectors drawn from poles and zeros to that point.</a:t>
-            </a:r>
-            <a:endParaRPr lang="en-US" sz="1800" b="0" u="none" strike="noStrike">
-              <a:solidFill>
-                <a:srgbClr val="000000"/>
-              </a:solidFill>
-              <a:effectLst/>
-              <a:uFillTx/>
-              <a:latin typeface="Arial"/>
-            </a:endParaRPr>
-          </a:p>
-        </p:txBody>
-      </p:sp>
+      <mc:AlternateContent xmlns:mc="http://schemas.openxmlformats.org/markup-compatibility/2006">
+        <mc:Choice xmlns:a14="http://schemas.microsoft.com/office/drawing/2010/main" Requires="a14">
+          <p:sp>
+            <p:nvSpPr>
+              <p:cNvPr id="25" name="Text 5"/>
+              <p:cNvSpPr/>
+              <p:nvPr/>
+            </p:nvSpPr>
+            <p:spPr>
+              <a:xfrm>
+                <a:off x="822960" y="1554480"/>
+                <a:ext cx="10515240" cy="731160"/>
+              </a:xfrm>
+              <a:prstGeom prst="rect">
+                <a:avLst/>
+              </a:prstGeom>
+              <a:solidFill>
+                <a:srgbClr val="F4F7FB"/>
+              </a:solidFill>
+              <a:ln w="12700">
+                <a:solidFill>
+                  <a:srgbClr val="D7E0EA"/>
+                </a:solidFill>
+                <a:round/>
+              </a:ln>
+            </p:spPr>
+            <p:style>
+              <a:lnRef idx="0">
+                <a:scrgbClr r="0" g="0" b="0"/>
+              </a:lnRef>
+              <a:fillRef idx="0">
+                <a:scrgbClr r="0" g="0" b="0"/>
+              </a:fillRef>
+              <a:effectRef idx="0">
+                <a:scrgbClr r="0" g="0" b="0"/>
+              </a:effectRef>
+              <a:fontRef idx="minor"/>
+            </p:style>
+            <p:txBody>
+              <a:bodyPr lIns="360" tIns="360" rIns="360" bIns="360" anchor="ctr">
+                <a:noAutofit/>
+              </a:bodyPr>
+              <a:lstStyle/>
+              <a:p>
+                <a:pPr algn="ctr" defTabSz="914400">
+                  <a:lnSpc>
+                    <a:spcPct val="100000"/>
+                  </a:lnSpc>
+                  <a:tabLst>
+                    <a:tab pos="0" algn="l"/>
+                  </a:tabLst>
+                </a:pPr>
+                <a14:m>
+                  <m:oMathPara xmlns:m="http://schemas.openxmlformats.org/officeDocument/2006/math">
+                    <m:oMath>
+                      <m:r>
+                        <a:rPr lang="en-US" sz="2400" b="1" i="1" u="none" strike="noStrike" dirty="0" smtClean="0">
+                          <a:solidFill>
+                            <a:srgbClr val="17365D"/>
+                          </a:solidFill>
+                          <a:effectLst/>
+                          <a:uFillTx/>
+                          <a:latin typeface="Cambria Math" panose="02040503050406030204" pitchFamily="18" charset="0"/>
+                        </a:rPr>
+                        <m:t>𝑯</m:t>
+                      </m:r>
+                      <m:r>
+                        <a:rPr lang="en-US" sz="2400" b="1" i="1" u="none" strike="noStrike" dirty="0">
+                          <a:solidFill>
+                            <a:srgbClr val="17365D"/>
+                          </a:solidFill>
+                          <a:effectLst/>
+                          <a:uFillTx/>
+                          <a:latin typeface="Cambria Math" panose="02040503050406030204" pitchFamily="18" charset="0"/>
+                        </a:rPr>
+                        <m:t>(</m:t>
+                      </m:r>
+                      <m:sSup>
+                        <m:sSupPr>
+                          <m:ctrlPr>
+                            <a:rPr lang="en-US" sz="2400" b="1" i="1" u="none" strike="noStrike" dirty="0">
+                              <a:solidFill>
+                                <a:srgbClr val="17365D"/>
+                              </a:solidFill>
+                              <a:effectLst/>
+                              <a:uFillTx/>
+                              <a:latin typeface="Cambria Math" panose="02040503050406030204" pitchFamily="18" charset="0"/>
+                            </a:rPr>
+                          </m:ctrlPr>
+                        </m:sSupPr>
+                        <m:e>
+                          <m:r>
+                            <a:rPr lang="en-US" sz="2400" b="1" i="1" u="none" strike="noStrike" dirty="0">
+                              <a:solidFill>
+                                <a:srgbClr val="17365D"/>
+                              </a:solidFill>
+                              <a:effectLst/>
+                              <a:uFillTx/>
+                              <a:latin typeface="Cambria Math" panose="02040503050406030204" pitchFamily="18" charset="0"/>
+                            </a:rPr>
+                            <m:t>𝒆</m:t>
+                          </m:r>
+                        </m:e>
+                        <m:sup>
+                          <m:r>
+                            <a:rPr lang="en-US" sz="2400" b="1" i="1" u="none" strike="noStrike" dirty="0">
+                              <a:solidFill>
+                                <a:srgbClr val="17365D"/>
+                              </a:solidFill>
+                              <a:effectLst/>
+                              <a:uFillTx/>
+                              <a:latin typeface="Cambria Math" panose="02040503050406030204" pitchFamily="18" charset="0"/>
+                            </a:rPr>
+                            <m:t>𝒋</m:t>
+                          </m:r>
+                          <m:r>
+                            <a:rPr lang="en-US" sz="2400" b="1" i="1" u="none" strike="noStrike" dirty="0" smtClean="0">
+                              <a:solidFill>
+                                <a:srgbClr val="17365D"/>
+                              </a:solidFill>
+                              <a:effectLst/>
+                              <a:uFillTx/>
+                              <a:latin typeface="Cambria Math" panose="02040503050406030204" pitchFamily="18" charset="0"/>
+                              <a:ea typeface="Cambria Math" panose="02040503050406030204" pitchFamily="18" charset="0"/>
+                            </a:rPr>
+                            <m:t>𝝎</m:t>
+                          </m:r>
+                        </m:sup>
+                      </m:sSup>
+                      <m:r>
+                        <a:rPr lang="en-US" sz="2400" b="1" i="1" u="none" strike="noStrike" dirty="0">
+                          <a:solidFill>
+                            <a:srgbClr val="17365D"/>
+                          </a:solidFill>
+                          <a:effectLst/>
+                          <a:uFillTx/>
+                          <a:latin typeface="Cambria Math" panose="02040503050406030204" pitchFamily="18" charset="0"/>
+                        </a:rPr>
+                        <m:t>)=</m:t>
+                      </m:r>
+                      <m:r>
+                        <a:rPr lang="en-US" sz="2400" b="1" i="1" u="none" strike="noStrike" dirty="0">
+                          <a:solidFill>
+                            <a:srgbClr val="17365D"/>
+                          </a:solidFill>
+                          <a:effectLst/>
+                          <a:uFillTx/>
+                          <a:latin typeface="Cambria Math" panose="02040503050406030204" pitchFamily="18" charset="0"/>
+                        </a:rPr>
+                        <m:t>𝑯</m:t>
+                      </m:r>
+                      <m:d>
+                        <m:dPr>
+                          <m:ctrlPr>
+                            <a:rPr lang="en-US" sz="2400" b="1" i="1" u="none" strike="noStrike" dirty="0">
+                              <a:solidFill>
+                                <a:srgbClr val="17365D"/>
+                              </a:solidFill>
+                              <a:effectLst/>
+                              <a:uFillTx/>
+                              <a:latin typeface="Cambria Math" panose="02040503050406030204" pitchFamily="18" charset="0"/>
+                            </a:rPr>
+                          </m:ctrlPr>
+                        </m:dPr>
+                        <m:e>
+                          <m:r>
+                            <a:rPr lang="en-US" sz="2400" b="1" i="1" u="none" strike="noStrike" dirty="0">
+                              <a:solidFill>
+                                <a:srgbClr val="17365D"/>
+                              </a:solidFill>
+                              <a:effectLst/>
+                              <a:uFillTx/>
+                              <a:latin typeface="Cambria Math" panose="02040503050406030204" pitchFamily="18" charset="0"/>
+                            </a:rPr>
+                            <m:t>𝒛</m:t>
+                          </m:r>
+                        </m:e>
+                      </m:d>
+                      <m:sSub>
+                        <m:sSubPr>
+                          <m:ctrlPr>
+                            <a:rPr lang="en-US" sz="2400" b="1" i="1" u="none" strike="noStrike" dirty="0" smtClean="0">
+                              <a:solidFill>
+                                <a:srgbClr val="17365D"/>
+                              </a:solidFill>
+                              <a:effectLst/>
+                              <a:uFillTx/>
+                              <a:latin typeface="Cambria Math" panose="02040503050406030204" pitchFamily="18" charset="0"/>
+                            </a:rPr>
+                          </m:ctrlPr>
+                        </m:sSubPr>
+                        <m:e>
+                          <m:d>
+                            <m:dPr>
+                              <m:begChr m:val=""/>
+                              <m:endChr m:val="|"/>
+                              <m:ctrlPr>
+                                <a:rPr lang="en-US" sz="2400" b="1" i="1" u="none" strike="noStrike" dirty="0">
+                                  <a:solidFill>
+                                    <a:srgbClr val="17365D"/>
+                                  </a:solidFill>
+                                  <a:effectLst/>
+                                  <a:uFillTx/>
+                                  <a:latin typeface="Cambria Math" panose="02040503050406030204" pitchFamily="18" charset="0"/>
+                                </a:rPr>
+                              </m:ctrlPr>
+                            </m:dPr>
+                            <m:e>
+                              <m:r>
+                                <a:rPr lang="en-US" sz="2400" b="1" i="1" u="none" strike="noStrike" dirty="0">
+                                  <a:solidFill>
+                                    <a:srgbClr val="17365D"/>
+                                  </a:solidFill>
+                                  <a:effectLst/>
+                                  <a:uFillTx/>
+                                  <a:latin typeface="Cambria Math" panose="02040503050406030204" pitchFamily="18" charset="0"/>
+                                </a:rPr>
+                                <m:t>​</m:t>
+                              </m:r>
+                            </m:e>
+                          </m:d>
+                        </m:e>
+                        <m:sub>
+                          <m:r>
+                            <a:rPr lang="en-US" sz="2400" b="1" i="1" u="none" strike="noStrike" dirty="0" smtClean="0">
+                              <a:solidFill>
+                                <a:srgbClr val="17365D"/>
+                              </a:solidFill>
+                              <a:effectLst/>
+                              <a:uFillTx/>
+                              <a:latin typeface="Cambria Math" panose="02040503050406030204" pitchFamily="18" charset="0"/>
+                            </a:rPr>
+                            <m:t>𝒛</m:t>
+                          </m:r>
+                          <m:r>
+                            <a:rPr lang="en-US" sz="2400" b="1" i="1" u="none" strike="noStrike" dirty="0" smtClean="0">
+                              <a:solidFill>
+                                <a:srgbClr val="17365D"/>
+                              </a:solidFill>
+                              <a:effectLst/>
+                              <a:uFillTx/>
+                              <a:latin typeface="Cambria Math" panose="02040503050406030204" pitchFamily="18" charset="0"/>
+                            </a:rPr>
+                            <m:t>=</m:t>
+                          </m:r>
+                          <m:sSup>
+                            <m:sSupPr>
+                              <m:ctrlPr>
+                                <a:rPr lang="en-US" sz="2400" b="1" i="1" u="none" strike="noStrike" dirty="0" smtClean="0">
+                                  <a:solidFill>
+                                    <a:srgbClr val="17365D"/>
+                                  </a:solidFill>
+                                  <a:effectLst/>
+                                  <a:uFillTx/>
+                                  <a:latin typeface="Cambria Math" panose="02040503050406030204" pitchFamily="18" charset="0"/>
+                                </a:rPr>
+                              </m:ctrlPr>
+                            </m:sSupPr>
+                            <m:e>
+                              <m:r>
+                                <a:rPr lang="en-US" sz="2400" b="1" i="1" u="none" strike="noStrike" dirty="0" smtClean="0">
+                                  <a:solidFill>
+                                    <a:srgbClr val="17365D"/>
+                                  </a:solidFill>
+                                  <a:effectLst/>
+                                  <a:uFillTx/>
+                                  <a:latin typeface="Cambria Math" panose="02040503050406030204" pitchFamily="18" charset="0"/>
+                                </a:rPr>
+                                <m:t>𝒆</m:t>
+                              </m:r>
+                            </m:e>
+                            <m:sup>
+                              <m:r>
+                                <a:rPr lang="en-US" sz="2400" b="1" i="1" u="none" strike="noStrike" dirty="0" smtClean="0">
+                                  <a:solidFill>
+                                    <a:srgbClr val="17365D"/>
+                                  </a:solidFill>
+                                  <a:effectLst/>
+                                  <a:uFillTx/>
+                                  <a:latin typeface="Cambria Math" panose="02040503050406030204" pitchFamily="18" charset="0"/>
+                                </a:rPr>
+                                <m:t>𝒋</m:t>
+                              </m:r>
+                              <m:r>
+                                <a:rPr lang="en-US" sz="2400" b="1" i="1" u="none" strike="noStrike" dirty="0" smtClean="0">
+                                  <a:solidFill>
+                                    <a:srgbClr val="17365D"/>
+                                  </a:solidFill>
+                                  <a:effectLst/>
+                                  <a:uFillTx/>
+                                  <a:latin typeface="Cambria Math" panose="02040503050406030204" pitchFamily="18" charset="0"/>
+                                  <a:ea typeface="Cambria Math" panose="02040503050406030204" pitchFamily="18" charset="0"/>
+                                </a:rPr>
+                                <m:t>𝝎</m:t>
+                              </m:r>
+                            </m:sup>
+                          </m:sSup>
+                        </m:sub>
+                      </m:sSub>
+                    </m:oMath>
+                  </m:oMathPara>
+                </a14:m>
+              </a:p>
+            </p:txBody>
+          </p:sp>
+        </mc:Choice>
+        <mc:Fallback>
+          <p:sp>
+            <p:nvSpPr>
+              <p:cNvPr id="25" name="Text 5"/>
+              <p:cNvSpPr>
+                <a:spLocks noRot="1" noChangeAspect="1" noMove="1" noResize="1" noEditPoints="1" noAdjustHandles="1" noChangeArrowheads="1" noChangeShapeType="1" noTextEdit="1"/>
+              </p:cNvSpPr>
+              <p:nvPr/>
+            </p:nvSpPr>
+            <p:spPr>
+              <a:xfrm>
+                <a:off x="822960" y="1554480"/>
+                <a:ext cx="10515240" cy="731160"/>
+              </a:xfrm>
+              <a:prstGeom prst="rect">
+                <a:avLst/>
+              </a:prstGeom>
+              <a:blipFill>
+                <a:blip r:embed="rId3"/>
+                <a:stretch>
+                  <a:fillRect/>
+                </a:stretch>
+              </a:blipFill>
+              <a:ln w="12700">
+                <a:solidFill>
+                  <a:srgbClr val="D7E0EA"/>
+                </a:solidFill>
+                <a:round/>
+              </a:ln>
+            </p:spPr>
+            <p:txBody>
+              <a:bodyPr/>
+              <a:lstStyle/>
+              <a:p>
+                <a:r>
+                  <a:rPr lang="en-US">
+                    <a:noFill/>
+                  </a:rPr>
+                  <a:t> </a:t>
+                </a:r>
+              </a:p>
+            </p:txBody>
+          </p:sp>
+        </mc:Fallback>
+      </mc:AlternateContent>
+      <mc:AlternateContent xmlns:mc="http://schemas.openxmlformats.org/markup-compatibility/2006">
+        <mc:Choice xmlns:a14="http://schemas.microsoft.com/office/drawing/2010/main" Requires="a14">
+          <p:sp>
+            <p:nvSpPr>
+              <p:cNvPr id="26" name="Text 6"/>
+              <p:cNvSpPr/>
+              <p:nvPr/>
+            </p:nvSpPr>
+            <p:spPr>
+              <a:xfrm>
+                <a:off x="822960" y="2560320"/>
+                <a:ext cx="10423800" cy="2194200"/>
+              </a:xfrm>
+              <a:prstGeom prst="rect">
+                <a:avLst/>
+              </a:prstGeom>
+              <a:noFill/>
+              <a:ln w="0">
+                <a:noFill/>
+              </a:ln>
+            </p:spPr>
+            <p:style>
+              <a:lnRef idx="0">
+                <a:scrgbClr r="0" g="0" b="0"/>
+              </a:lnRef>
+              <a:fillRef idx="0">
+                <a:scrgbClr r="0" g="0" b="0"/>
+              </a:fillRef>
+              <a:effectRef idx="0">
+                <a:scrgbClr r="0" g="0" b="0"/>
+              </a:effectRef>
+              <a:fontRef idx="minor"/>
+            </p:style>
+            <p:txBody>
+              <a:bodyPr lIns="720" tIns="720" rIns="720" bIns="720" anchor="t">
+                <a:noAutofit/>
+              </a:bodyPr>
+              <a:lstStyle/>
+              <a:p>
+                <a:pPr marL="228600" indent="-228600" defTabSz="914400">
+                  <a:lnSpc>
+                    <a:spcPct val="100000"/>
+                  </a:lnSpc>
+                  <a:buClr>
+                    <a:srgbClr val="1F2937"/>
+                  </a:buClr>
+                  <a:buFont typeface="Symbol" charset="2"/>
+                  <a:buChar char=""/>
+                </a:pPr>
+                <a:r>
+                  <a:rPr lang="en-US" sz="1800" b="0" u="none" strike="noStrike" dirty="0">
+                    <a:solidFill>
+                      <a:srgbClr val="1F2937"/>
+                    </a:solidFill>
+                    <a:effectLst/>
+                    <a:uFillTx/>
+                    <a:latin typeface="Aptos"/>
+                  </a:rPr>
+                  <a:t>Every digital frequency </a:t>
+                </a:r>
+                <a14:m>
+                  <m:oMath xmlns:m="http://schemas.openxmlformats.org/officeDocument/2006/math">
+                    <m:r>
+                      <a:rPr lang="en-US" sz="1800" b="0" i="1" u="none" strike="noStrike" dirty="0" smtClean="0">
+                        <a:solidFill>
+                          <a:srgbClr val="1F2937"/>
+                        </a:solidFill>
+                        <a:effectLst/>
+                        <a:uFillTx/>
+                        <a:latin typeface="Cambria Math" panose="02040503050406030204" pitchFamily="18" charset="0"/>
+                        <a:ea typeface="Cambria Math" panose="02040503050406030204" pitchFamily="18" charset="0"/>
+                      </a:rPr>
+                      <m:t>𝜔</m:t>
+                    </m:r>
+                  </m:oMath>
+                </a14:m>
+                <a:r>
+                  <a:rPr lang="en-US" sz="1800" b="0" u="none" strike="noStrike" dirty="0">
+                    <a:solidFill>
+                      <a:srgbClr val="1F2937"/>
+                    </a:solidFill>
+                    <a:effectLst/>
+                    <a:uFillTx/>
+                    <a:latin typeface="Aptos"/>
+                  </a:rPr>
+                  <a:t> corresponds to one point </a:t>
+                </a:r>
+                <a14:m>
+                  <m:oMath xmlns:m="http://schemas.openxmlformats.org/officeDocument/2006/math">
+                    <m:sSup>
+                      <m:sSupPr>
+                        <m:ctrlPr>
+                          <a:rPr lang="en-US" sz="1800" b="0" i="1" u="none" strike="noStrike" smtClean="0">
+                            <a:solidFill>
+                              <a:srgbClr val="1F2937"/>
+                            </a:solidFill>
+                            <a:effectLst/>
+                            <a:uFillTx/>
+                            <a:latin typeface="Cambria Math" panose="02040503050406030204" pitchFamily="18" charset="0"/>
+                          </a:rPr>
+                        </m:ctrlPr>
+                      </m:sSupPr>
+                      <m:e>
+                        <m:r>
+                          <a:rPr lang="en-US" sz="1800" b="0" i="1" u="none" strike="noStrike" smtClean="0">
+                            <a:solidFill>
+                              <a:srgbClr val="1F2937"/>
+                            </a:solidFill>
+                            <a:effectLst/>
+                            <a:uFillTx/>
+                            <a:latin typeface="Cambria Math" panose="02040503050406030204" pitchFamily="18" charset="0"/>
+                          </a:rPr>
+                          <m:t>𝑒</m:t>
+                        </m:r>
+                      </m:e>
+                      <m:sup>
+                        <m:r>
+                          <a:rPr lang="en-US" sz="1800" b="0" i="1" u="none" strike="noStrike" smtClean="0">
+                            <a:solidFill>
+                              <a:srgbClr val="1F2937"/>
+                            </a:solidFill>
+                            <a:effectLst/>
+                            <a:uFillTx/>
+                            <a:latin typeface="Cambria Math" panose="02040503050406030204" pitchFamily="18" charset="0"/>
+                          </a:rPr>
+                          <m:t>𝑗</m:t>
+                        </m:r>
+                        <m:r>
+                          <a:rPr lang="en-US" sz="1800" b="0" i="1" u="none" strike="noStrike" smtClean="0">
+                            <a:solidFill>
+                              <a:srgbClr val="1F2937"/>
+                            </a:solidFill>
+                            <a:effectLst/>
+                            <a:uFillTx/>
+                            <a:latin typeface="Cambria Math" panose="02040503050406030204" pitchFamily="18" charset="0"/>
+                            <a:ea typeface="Cambria Math" panose="02040503050406030204" pitchFamily="18" charset="0"/>
+                          </a:rPr>
+                          <m:t>𝜔</m:t>
+                        </m:r>
+                      </m:sup>
+                    </m:sSup>
+                  </m:oMath>
+                </a14:m>
+                <a:r>
+                  <a:rPr lang="en-US" sz="1800" b="0" u="none" strike="noStrike" dirty="0">
+                    <a:solidFill>
+                      <a:srgbClr val="1F2937"/>
+                    </a:solidFill>
+                    <a:effectLst/>
+                    <a:uFillTx/>
+                    <a:latin typeface="Aptos"/>
+                  </a:rPr>
+                  <a:t> the unit circle.</a:t>
+                </a:r>
+                <a:endParaRPr lang="en-US" sz="1800" b="0" u="none" strike="noStrike" dirty="0">
+                  <a:solidFill>
+                    <a:srgbClr val="000000"/>
+                  </a:solidFill>
+                  <a:effectLst/>
+                  <a:uFillTx/>
+                  <a:latin typeface="Arial"/>
+                </a:endParaRPr>
+              </a:p>
+              <a:p>
+                <a:pPr marL="228600" indent="-228600" defTabSz="914400">
+                  <a:lnSpc>
+                    <a:spcPct val="100000"/>
+                  </a:lnSpc>
+                  <a:buClr>
+                    <a:srgbClr val="1F2937"/>
+                  </a:buClr>
+                  <a:buFont typeface="Symbol" charset="2"/>
+                  <a:buChar char=""/>
+                </a:pPr>
+                <a:r>
+                  <a:rPr lang="en-US" sz="1800" b="0" u="none" strike="noStrike" dirty="0">
+                    <a:solidFill>
+                      <a:srgbClr val="1F2937"/>
+                    </a:solidFill>
+                    <a:effectLst/>
+                    <a:uFillTx/>
+                    <a:latin typeface="Aptos"/>
+                  </a:rPr>
+                  <a:t>Magnitude and phase can be read geometrically from vectors drawn from poles and zeros to that point.</a:t>
+                </a:r>
+                <a:endParaRPr lang="en-US" sz="1800" b="0" u="none" strike="noStrike" dirty="0">
+                  <a:solidFill>
+                    <a:srgbClr val="000000"/>
+                  </a:solidFill>
+                  <a:effectLst/>
+                  <a:uFillTx/>
+                  <a:latin typeface="Arial"/>
+                </a:endParaRPr>
+              </a:p>
+            </p:txBody>
+          </p:sp>
+        </mc:Choice>
+        <mc:Fallback>
+          <p:sp>
+            <p:nvSpPr>
+              <p:cNvPr id="26" name="Text 6"/>
+              <p:cNvSpPr>
+                <a:spLocks noRot="1" noChangeAspect="1" noMove="1" noResize="1" noEditPoints="1" noAdjustHandles="1" noChangeArrowheads="1" noChangeShapeType="1" noTextEdit="1"/>
+              </p:cNvSpPr>
+              <p:nvPr/>
+            </p:nvSpPr>
+            <p:spPr>
+              <a:xfrm>
+                <a:off x="822960" y="2560320"/>
+                <a:ext cx="10423800" cy="2194200"/>
+              </a:xfrm>
+              <a:prstGeom prst="rect">
+                <a:avLst/>
+              </a:prstGeom>
+              <a:blipFill>
+                <a:blip r:embed="rId4"/>
+                <a:stretch>
+                  <a:fillRect l="-1345" t="-3611"/>
+                </a:stretch>
+              </a:blipFill>
+              <a:ln w="0">
+                <a:noFill/>
+              </a:ln>
+            </p:spPr>
+            <p:txBody>
+              <a:bodyPr/>
+              <a:lstStyle/>
+              <a:p>
+                <a:r>
+                  <a:rPr lang="en-US">
+                    <a:noFill/>
+                  </a:rPr>
+                  <a:t> </a:t>
+                </a:r>
+              </a:p>
+            </p:txBody>
+          </p:sp>
+        </mc:Fallback>
+      </mc:AlternateContent>
     </p:spTree>
   </p:cSld>
   <p:clrMapOvr>
@@ -15352,78 +15770,617 @@
           </a:p>
         </p:txBody>
       </p:sp>
-      <p:sp>
-        <p:nvSpPr>
-          <p:cNvPr id="32" name="Text 5"/>
-          <p:cNvSpPr/>
-          <p:nvPr/>
-        </p:nvSpPr>
-        <p:spPr>
-          <a:xfrm>
-            <a:off x="685800" y="1371600"/>
-            <a:ext cx="5577480" cy="914040"/>
-          </a:xfrm>
-          <a:prstGeom prst="rect">
-            <a:avLst/>
-          </a:prstGeom>
-          <a:solidFill>
-            <a:srgbClr val="F4F7FB"/>
-          </a:solidFill>
-          <a:ln w="12700">
-            <a:solidFill>
-              <a:srgbClr val="D7E0EA"/>
-            </a:solidFill>
-            <a:round/>
-          </a:ln>
-        </p:spPr>
-        <p:style>
-          <a:lnRef idx="0">
-            <a:scrgbClr r="0" g="0" b="0"/>
-          </a:lnRef>
-          <a:fillRef idx="0">
-            <a:scrgbClr r="0" g="0" b="0"/>
-          </a:fillRef>
-          <a:effectRef idx="0">
-            <a:scrgbClr r="0" g="0" b="0"/>
-          </a:effectRef>
-          <a:fontRef idx="minor"/>
-        </p:style>
-        <p:txBody>
-          <a:bodyPr lIns="360" tIns="360" rIns="360" bIns="360" anchor="ctr">
-            <a:noAutofit/>
-          </a:bodyPr>
-          <a:lstStyle/>
-          <a:p>
-            <a:pPr algn="ctr" defTabSz="914400">
-              <a:lnSpc>
-                <a:spcPct val="100000"/>
-              </a:lnSpc>
-              <a:tabLst>
-                <a:tab pos="0" algn="l"/>
-              </a:tabLst>
-            </a:pPr>
-            <a:r>
-              <a:rPr lang="en-US" sz="2000" b="1" u="none" strike="noStrike">
-                <a:solidFill>
-                  <a:srgbClr val="17365D"/>
-                </a:solidFill>
-                <a:effectLst/>
-                <a:uFillTx/>
-                <a:latin typeface="Aptos"/>
-              </a:rPr>
-              <a:t>$$|H(e^{j\omega})|=|K|\frac{\prod_i|e^{j\omega}-z_i|}{\prod_k|e^{j\omega}-p_k|}$$</a:t>
-            </a:r>
-            <a:endParaRPr lang="en-US" sz="2000" b="0" u="none" strike="noStrike">
-              <a:solidFill>
-                <a:srgbClr val="000000"/>
-              </a:solidFill>
-              <a:effectLst/>
-              <a:uFillTx/>
-              <a:latin typeface="Arial"/>
-            </a:endParaRPr>
-          </a:p>
-        </p:txBody>
-      </p:sp>
+      <mc:AlternateContent xmlns:mc="http://schemas.openxmlformats.org/markup-compatibility/2006">
+        <mc:Choice xmlns:a14="http://schemas.microsoft.com/office/drawing/2010/main" Requires="a14">
+          <p:sp>
+            <p:nvSpPr>
+              <p:cNvPr id="32" name="Text 5"/>
+              <p:cNvSpPr/>
+              <p:nvPr/>
+            </p:nvSpPr>
+            <p:spPr>
+              <a:xfrm>
+                <a:off x="685800" y="1371600"/>
+                <a:ext cx="5577480" cy="914040"/>
+              </a:xfrm>
+              <a:prstGeom prst="rect">
+                <a:avLst/>
+              </a:prstGeom>
+              <a:solidFill>
+                <a:srgbClr val="F4F7FB"/>
+              </a:solidFill>
+              <a:ln w="12700">
+                <a:solidFill>
+                  <a:srgbClr val="D7E0EA"/>
+                </a:solidFill>
+                <a:round/>
+              </a:ln>
+            </p:spPr>
+            <p:style>
+              <a:lnRef idx="0">
+                <a:scrgbClr r="0" g="0" b="0"/>
+              </a:lnRef>
+              <a:fillRef idx="0">
+                <a:scrgbClr r="0" g="0" b="0"/>
+              </a:fillRef>
+              <a:effectRef idx="0">
+                <a:scrgbClr r="0" g="0" b="0"/>
+              </a:effectRef>
+              <a:fontRef idx="minor"/>
+            </p:style>
+            <p:txBody>
+              <a:bodyPr lIns="360" tIns="360" rIns="360" bIns="360" anchor="ctr">
+                <a:noAutofit/>
+              </a:bodyPr>
+              <a:lstStyle/>
+              <a:p>
+                <a:pPr algn="ctr" defTabSz="914400">
+                  <a:lnSpc>
+                    <a:spcPct val="100000"/>
+                  </a:lnSpc>
+                  <a:tabLst>
+                    <a:tab pos="0" algn="l"/>
+                  </a:tabLst>
+                </a:pPr>
+                <a14:m>
+                  <m:oMathPara xmlns:m="http://schemas.openxmlformats.org/officeDocument/2006/math">
+                    <m:oMath>
+                      <m:d>
+                        <m:dPr>
+                          <m:begChr m:val="|"/>
+                          <m:endChr m:val="|"/>
+                          <m:ctrlPr>
+                            <a:rPr lang="en-US" sz="2000" b="0" i="1" u="none" strike="noStrike" smtClean="0">
+                              <a:solidFill>
+                                <a:srgbClr val="000000"/>
+                              </a:solidFill>
+                              <a:effectLst/>
+                              <a:uFillTx/>
+                              <a:latin typeface="Cambria Math" panose="02040503050406030204" pitchFamily="18" charset="0"/>
+                            </a:rPr>
+                          </m:ctrlPr>
+                        </m:dPr>
+                        <m:e>
+                          <m:r>
+                            <a:rPr lang="en-US" sz="2000" b="0" i="1" u="none" strike="noStrike" smtClean="0">
+                              <a:solidFill>
+                                <a:srgbClr val="000000"/>
+                              </a:solidFill>
+                              <a:effectLst/>
+                              <a:uFillTx/>
+                              <a:latin typeface="Cambria Math" panose="02040503050406030204" pitchFamily="18" charset="0"/>
+                            </a:rPr>
+                            <m:t>𝐻</m:t>
+                          </m:r>
+                          <m:d>
+                            <m:dPr>
+                              <m:ctrlPr>
+                                <a:rPr lang="en-US" sz="2000" b="0" i="1" u="none" strike="noStrike" smtClean="0">
+                                  <a:solidFill>
+                                    <a:srgbClr val="000000"/>
+                                  </a:solidFill>
+                                  <a:effectLst/>
+                                  <a:uFillTx/>
+                                  <a:latin typeface="Cambria Math" panose="02040503050406030204" pitchFamily="18" charset="0"/>
+                                </a:rPr>
+                              </m:ctrlPr>
+                            </m:dPr>
+                            <m:e>
+                              <m:sSup>
+                                <m:sSupPr>
+                                  <m:ctrlPr>
+                                    <a:rPr lang="en-US" sz="2000" b="0" i="1" u="none" strike="noStrike" smtClean="0">
+                                      <a:solidFill>
+                                        <a:srgbClr val="000000"/>
+                                      </a:solidFill>
+                                      <a:effectLst/>
+                                      <a:uFillTx/>
+                                      <a:latin typeface="Cambria Math" panose="02040503050406030204" pitchFamily="18" charset="0"/>
+                                    </a:rPr>
+                                  </m:ctrlPr>
+                                </m:sSupPr>
+                                <m:e>
+                                  <m:r>
+                                    <a:rPr lang="en-US" sz="2000" b="0" i="1" u="none" strike="noStrike" smtClean="0">
+                                      <a:solidFill>
+                                        <a:srgbClr val="000000"/>
+                                      </a:solidFill>
+                                      <a:effectLst/>
+                                      <a:uFillTx/>
+                                      <a:latin typeface="Cambria Math" panose="02040503050406030204" pitchFamily="18" charset="0"/>
+                                    </a:rPr>
+                                    <m:t>𝑒</m:t>
+                                  </m:r>
+                                </m:e>
+                                <m:sup>
+                                  <m:r>
+                                    <a:rPr lang="en-US" sz="2000" b="0" i="1" u="none" strike="noStrike" smtClean="0">
+                                      <a:solidFill>
+                                        <a:srgbClr val="000000"/>
+                                      </a:solidFill>
+                                      <a:effectLst/>
+                                      <a:uFillTx/>
+                                      <a:latin typeface="Cambria Math" panose="02040503050406030204" pitchFamily="18" charset="0"/>
+                                    </a:rPr>
+                                    <m:t>𝑗</m:t>
+                                  </m:r>
+                                  <m:r>
+                                    <a:rPr lang="en-US" sz="2000" b="0" i="1" u="none" strike="noStrike" smtClean="0">
+                                      <a:solidFill>
+                                        <a:srgbClr val="000000"/>
+                                      </a:solidFill>
+                                      <a:effectLst/>
+                                      <a:uFillTx/>
+                                      <a:latin typeface="Cambria Math" panose="02040503050406030204" pitchFamily="18" charset="0"/>
+                                      <a:ea typeface="Cambria Math" panose="02040503050406030204" pitchFamily="18" charset="0"/>
+                                    </a:rPr>
+                                    <m:t>𝜔</m:t>
+                                  </m:r>
+                                </m:sup>
+                              </m:sSup>
+                            </m:e>
+                          </m:d>
+                        </m:e>
+                      </m:d>
+                      <m:r>
+                        <a:rPr lang="en-US" sz="2000" b="0" i="1" u="none" strike="noStrike" smtClean="0">
+                          <a:solidFill>
+                            <a:srgbClr val="000000"/>
+                          </a:solidFill>
+                          <a:effectLst/>
+                          <a:uFillTx/>
+                          <a:latin typeface="Cambria Math" panose="02040503050406030204" pitchFamily="18" charset="0"/>
+                          <a:ea typeface="Cambria Math" panose="02040503050406030204" pitchFamily="18" charset="0"/>
+                        </a:rPr>
+                        <m:t>=|</m:t>
+                      </m:r>
+                      <m:r>
+                        <a:rPr lang="en-US" sz="2000" b="0" i="1" u="none" strike="noStrike" smtClean="0">
+                          <a:solidFill>
+                            <a:srgbClr val="000000"/>
+                          </a:solidFill>
+                          <a:effectLst/>
+                          <a:uFillTx/>
+                          <a:latin typeface="Cambria Math" panose="02040503050406030204" pitchFamily="18" charset="0"/>
+                          <a:ea typeface="Cambria Math" panose="02040503050406030204" pitchFamily="18" charset="0"/>
+                        </a:rPr>
+                        <m:t>𝐾</m:t>
+                      </m:r>
+                      <m:r>
+                        <a:rPr lang="en-US" sz="2000" b="0" i="1" u="none" strike="noStrike" smtClean="0">
+                          <a:solidFill>
+                            <a:srgbClr val="000000"/>
+                          </a:solidFill>
+                          <a:effectLst/>
+                          <a:uFillTx/>
+                          <a:latin typeface="Cambria Math" panose="02040503050406030204" pitchFamily="18" charset="0"/>
+                          <a:ea typeface="Cambria Math" panose="02040503050406030204" pitchFamily="18" charset="0"/>
+                        </a:rPr>
+                        <m:t>|</m:t>
+                      </m:r>
+                      <m:f>
+                        <m:fPr>
+                          <m:ctrlPr>
+                            <a:rPr lang="en-US" sz="2000" b="0" i="1" u="none" strike="noStrike" smtClean="0">
+                              <a:solidFill>
+                                <a:srgbClr val="000000"/>
+                              </a:solidFill>
+                              <a:effectLst/>
+                              <a:uFillTx/>
+                              <a:latin typeface="Cambria Math" panose="02040503050406030204" pitchFamily="18" charset="0"/>
+                              <a:ea typeface="Cambria Math" panose="02040503050406030204" pitchFamily="18" charset="0"/>
+                            </a:rPr>
+                          </m:ctrlPr>
+                        </m:fPr>
+                        <m:num>
+                          <m:nary>
+                            <m:naryPr>
+                              <m:chr m:val="∏"/>
+                              <m:limLoc m:val="subSup"/>
+                              <m:supHide m:val="on"/>
+                              <m:ctrlPr>
+                                <a:rPr lang="en-US" sz="2000" b="0" i="1" u="none" strike="noStrike" smtClean="0">
+                                  <a:solidFill>
+                                    <a:srgbClr val="000000"/>
+                                  </a:solidFill>
+                                  <a:effectLst/>
+                                  <a:uFillTx/>
+                                  <a:latin typeface="Cambria Math" panose="02040503050406030204" pitchFamily="18" charset="0"/>
+                                  <a:ea typeface="Cambria Math" panose="02040503050406030204" pitchFamily="18" charset="0"/>
+                                </a:rPr>
+                              </m:ctrlPr>
+                            </m:naryPr>
+                            <m:sub>
+                              <m:r>
+                                <m:rPr>
+                                  <m:brk m:alnAt="9"/>
+                                </m:rPr>
+                                <a:rPr lang="en-US" sz="2000" b="0" i="1" u="none" strike="noStrike" smtClean="0">
+                                  <a:solidFill>
+                                    <a:srgbClr val="000000"/>
+                                  </a:solidFill>
+                                  <a:effectLst/>
+                                  <a:uFillTx/>
+                                  <a:latin typeface="Cambria Math" panose="02040503050406030204" pitchFamily="18" charset="0"/>
+                                  <a:ea typeface="Cambria Math" panose="02040503050406030204" pitchFamily="18" charset="0"/>
+                                </a:rPr>
+                                <m:t>𝑖</m:t>
+                              </m:r>
+                            </m:sub>
+                            <m:sup/>
+                            <m:e>
+                              <m:r>
+                                <a:rPr lang="en-US" sz="2000" b="0" i="1" u="none" strike="noStrike" smtClean="0">
+                                  <a:solidFill>
+                                    <a:srgbClr val="000000"/>
+                                  </a:solidFill>
+                                  <a:effectLst/>
+                                  <a:uFillTx/>
+                                  <a:latin typeface="Cambria Math" panose="02040503050406030204" pitchFamily="18" charset="0"/>
+                                  <a:ea typeface="Cambria Math" panose="02040503050406030204" pitchFamily="18" charset="0"/>
+                                </a:rPr>
+                                <m:t>|</m:t>
+                              </m:r>
+                              <m:sSup>
+                                <m:sSupPr>
+                                  <m:ctrlPr>
+                                    <a:rPr lang="en-US" sz="2000" b="0" i="1" u="none" strike="noStrike" smtClean="0">
+                                      <a:solidFill>
+                                        <a:srgbClr val="000000"/>
+                                      </a:solidFill>
+                                      <a:effectLst/>
+                                      <a:uFillTx/>
+                                      <a:latin typeface="Cambria Math" panose="02040503050406030204" pitchFamily="18" charset="0"/>
+                                      <a:ea typeface="Cambria Math" panose="02040503050406030204" pitchFamily="18" charset="0"/>
+                                    </a:rPr>
+                                  </m:ctrlPr>
+                                </m:sSupPr>
+                                <m:e>
+                                  <m:r>
+                                    <a:rPr lang="en-US" sz="2000" b="0" i="1" u="none" strike="noStrike" smtClean="0">
+                                      <a:solidFill>
+                                        <a:srgbClr val="000000"/>
+                                      </a:solidFill>
+                                      <a:effectLst/>
+                                      <a:uFillTx/>
+                                      <a:latin typeface="Cambria Math" panose="02040503050406030204" pitchFamily="18" charset="0"/>
+                                      <a:ea typeface="Cambria Math" panose="02040503050406030204" pitchFamily="18" charset="0"/>
+                                    </a:rPr>
+                                    <m:t>𝑒</m:t>
+                                  </m:r>
+                                </m:e>
+                                <m:sup>
+                                  <m:r>
+                                    <a:rPr lang="en-US" sz="2000" b="0" i="1" u="none" strike="noStrike" smtClean="0">
+                                      <a:solidFill>
+                                        <a:srgbClr val="000000"/>
+                                      </a:solidFill>
+                                      <a:effectLst/>
+                                      <a:uFillTx/>
+                                      <a:latin typeface="Cambria Math" panose="02040503050406030204" pitchFamily="18" charset="0"/>
+                                      <a:ea typeface="Cambria Math" panose="02040503050406030204" pitchFamily="18" charset="0"/>
+                                    </a:rPr>
+                                    <m:t>𝑗</m:t>
+                                  </m:r>
+                                  <m:r>
+                                    <a:rPr lang="en-US" sz="2000" b="0" i="1" u="none" strike="noStrike" smtClean="0">
+                                      <a:solidFill>
+                                        <a:srgbClr val="000000"/>
+                                      </a:solidFill>
+                                      <a:effectLst/>
+                                      <a:uFillTx/>
+                                      <a:latin typeface="Cambria Math" panose="02040503050406030204" pitchFamily="18" charset="0"/>
+                                      <a:ea typeface="Cambria Math" panose="02040503050406030204" pitchFamily="18" charset="0"/>
+                                    </a:rPr>
+                                    <m:t>𝜔</m:t>
+                                  </m:r>
+                                </m:sup>
+                              </m:sSup>
+                              <m:r>
+                                <a:rPr lang="en-US" sz="2000" b="0" i="1" u="none" strike="noStrike" smtClean="0">
+                                  <a:solidFill>
+                                    <a:srgbClr val="000000"/>
+                                  </a:solidFill>
+                                  <a:effectLst/>
+                                  <a:uFillTx/>
+                                  <a:latin typeface="Cambria Math" panose="02040503050406030204" pitchFamily="18" charset="0"/>
+                                  <a:ea typeface="Cambria Math" panose="02040503050406030204" pitchFamily="18" charset="0"/>
+                                </a:rPr>
+                                <m:t>−</m:t>
+                              </m:r>
+                              <m:sSub>
+                                <m:sSubPr>
+                                  <m:ctrlPr>
+                                    <a:rPr lang="en-US" sz="2000" b="0" i="1" u="none" strike="noStrike" smtClean="0">
+                                      <a:solidFill>
+                                        <a:srgbClr val="000000"/>
+                                      </a:solidFill>
+                                      <a:effectLst/>
+                                      <a:uFillTx/>
+                                      <a:latin typeface="Cambria Math" panose="02040503050406030204" pitchFamily="18" charset="0"/>
+                                      <a:ea typeface="Cambria Math" panose="02040503050406030204" pitchFamily="18" charset="0"/>
+                                    </a:rPr>
+                                  </m:ctrlPr>
+                                </m:sSubPr>
+                                <m:e>
+                                  <m:r>
+                                    <a:rPr lang="en-US" sz="2000" b="0" i="1" u="none" strike="noStrike" smtClean="0">
+                                      <a:solidFill>
+                                        <a:srgbClr val="000000"/>
+                                      </a:solidFill>
+                                      <a:effectLst/>
+                                      <a:uFillTx/>
+                                      <a:latin typeface="Cambria Math" panose="02040503050406030204" pitchFamily="18" charset="0"/>
+                                      <a:ea typeface="Cambria Math" panose="02040503050406030204" pitchFamily="18" charset="0"/>
+                                    </a:rPr>
+                                    <m:t>𝑧</m:t>
+                                  </m:r>
+                                </m:e>
+                                <m:sub>
+                                  <m:r>
+                                    <a:rPr lang="en-US" sz="2000" b="0" i="1" u="none" strike="noStrike" smtClean="0">
+                                      <a:solidFill>
+                                        <a:srgbClr val="000000"/>
+                                      </a:solidFill>
+                                      <a:effectLst/>
+                                      <a:uFillTx/>
+                                      <a:latin typeface="Cambria Math" panose="02040503050406030204" pitchFamily="18" charset="0"/>
+                                      <a:ea typeface="Cambria Math" panose="02040503050406030204" pitchFamily="18" charset="0"/>
+                                    </a:rPr>
+                                    <m:t>𝑖</m:t>
+                                  </m:r>
+                                </m:sub>
+                              </m:sSub>
+                              <m:r>
+                                <a:rPr lang="en-US" sz="2000" b="0" i="1" u="none" strike="noStrike" smtClean="0">
+                                  <a:solidFill>
+                                    <a:srgbClr val="000000"/>
+                                  </a:solidFill>
+                                  <a:effectLst/>
+                                  <a:uFillTx/>
+                                  <a:latin typeface="Cambria Math" panose="02040503050406030204" pitchFamily="18" charset="0"/>
+                                  <a:ea typeface="Cambria Math" panose="02040503050406030204" pitchFamily="18" charset="0"/>
+                                </a:rPr>
+                                <m:t>|</m:t>
+                              </m:r>
+                            </m:e>
+                          </m:nary>
+                        </m:num>
+                        <m:den>
+                          <m:nary>
+                            <m:naryPr>
+                              <m:chr m:val="∏"/>
+                              <m:limLoc m:val="subSup"/>
+                              <m:supHide m:val="on"/>
+                              <m:ctrlPr>
+                                <a:rPr lang="en-US" sz="2000" b="0" i="1" u="none" strike="noStrike" smtClean="0">
+                                  <a:solidFill>
+                                    <a:srgbClr val="000000"/>
+                                  </a:solidFill>
+                                  <a:effectLst/>
+                                  <a:uFillTx/>
+                                  <a:latin typeface="Cambria Math" panose="02040503050406030204" pitchFamily="18" charset="0"/>
+                                  <a:ea typeface="Cambria Math" panose="02040503050406030204" pitchFamily="18" charset="0"/>
+                                </a:rPr>
+                              </m:ctrlPr>
+                            </m:naryPr>
+                            <m:sub>
+                              <m:r>
+                                <m:rPr>
+                                  <m:brk m:alnAt="9"/>
+                                </m:rPr>
+                                <a:rPr lang="en-US" sz="2000" b="0" i="1" u="none" strike="noStrike" smtClean="0">
+                                  <a:solidFill>
+                                    <a:srgbClr val="000000"/>
+                                  </a:solidFill>
+                                  <a:effectLst/>
+                                  <a:uFillTx/>
+                                  <a:latin typeface="Cambria Math" panose="02040503050406030204" pitchFamily="18" charset="0"/>
+                                  <a:ea typeface="Cambria Math" panose="02040503050406030204" pitchFamily="18" charset="0"/>
+                                </a:rPr>
+                                <m:t>𝑘</m:t>
+                              </m:r>
+                            </m:sub>
+                            <m:sup/>
+                            <m:e>
+                              <m:r>
+                                <a:rPr lang="en-US" sz="2000" b="0" i="1" u="none" strike="noStrike" smtClean="0">
+                                  <a:solidFill>
+                                    <a:srgbClr val="000000"/>
+                                  </a:solidFill>
+                                  <a:effectLst/>
+                                  <a:uFillTx/>
+                                  <a:latin typeface="Cambria Math" panose="02040503050406030204" pitchFamily="18" charset="0"/>
+                                  <a:ea typeface="Cambria Math" panose="02040503050406030204" pitchFamily="18" charset="0"/>
+                                </a:rPr>
+                                <m:t>|</m:t>
+                              </m:r>
+                              <m:sSup>
+                                <m:sSupPr>
+                                  <m:ctrlPr>
+                                    <a:rPr lang="en-US" sz="2000" b="0" i="1" u="none" strike="noStrike" smtClean="0">
+                                      <a:solidFill>
+                                        <a:srgbClr val="000000"/>
+                                      </a:solidFill>
+                                      <a:effectLst/>
+                                      <a:uFillTx/>
+                                      <a:latin typeface="Cambria Math" panose="02040503050406030204" pitchFamily="18" charset="0"/>
+                                      <a:ea typeface="Cambria Math" panose="02040503050406030204" pitchFamily="18" charset="0"/>
+                                    </a:rPr>
+                                  </m:ctrlPr>
+                                </m:sSupPr>
+                                <m:e>
+                                  <m:r>
+                                    <a:rPr lang="en-US" sz="2000" b="0" i="1" u="none" strike="noStrike" smtClean="0">
+                                      <a:solidFill>
+                                        <a:srgbClr val="000000"/>
+                                      </a:solidFill>
+                                      <a:effectLst/>
+                                      <a:uFillTx/>
+                                      <a:latin typeface="Cambria Math" panose="02040503050406030204" pitchFamily="18" charset="0"/>
+                                      <a:ea typeface="Cambria Math" panose="02040503050406030204" pitchFamily="18" charset="0"/>
+                                    </a:rPr>
+                                    <m:t>𝑒</m:t>
+                                  </m:r>
+                                </m:e>
+                                <m:sup>
+                                  <m:r>
+                                    <a:rPr lang="en-US" sz="2000" b="0" i="1" u="none" strike="noStrike" smtClean="0">
+                                      <a:solidFill>
+                                        <a:srgbClr val="000000"/>
+                                      </a:solidFill>
+                                      <a:effectLst/>
+                                      <a:uFillTx/>
+                                      <a:latin typeface="Cambria Math" panose="02040503050406030204" pitchFamily="18" charset="0"/>
+                                      <a:ea typeface="Cambria Math" panose="02040503050406030204" pitchFamily="18" charset="0"/>
+                                    </a:rPr>
+                                    <m:t>𝑗</m:t>
+                                  </m:r>
+                                  <m:r>
+                                    <a:rPr lang="en-US" sz="2000" b="0" i="1" u="none" strike="noStrike" smtClean="0">
+                                      <a:solidFill>
+                                        <a:srgbClr val="000000"/>
+                                      </a:solidFill>
+                                      <a:effectLst/>
+                                      <a:uFillTx/>
+                                      <a:latin typeface="Cambria Math" panose="02040503050406030204" pitchFamily="18" charset="0"/>
+                                      <a:ea typeface="Cambria Math" panose="02040503050406030204" pitchFamily="18" charset="0"/>
+                                    </a:rPr>
+                                    <m:t>𝜔</m:t>
+                                  </m:r>
+                                </m:sup>
+                              </m:sSup>
+                              <m:r>
+                                <a:rPr lang="en-US" sz="2000" b="0" i="1" u="none" strike="noStrike" smtClean="0">
+                                  <a:solidFill>
+                                    <a:srgbClr val="000000"/>
+                                  </a:solidFill>
+                                  <a:effectLst/>
+                                  <a:uFillTx/>
+                                  <a:latin typeface="Cambria Math" panose="02040503050406030204" pitchFamily="18" charset="0"/>
+                                  <a:ea typeface="Cambria Math" panose="02040503050406030204" pitchFamily="18" charset="0"/>
+                                </a:rPr>
+                                <m:t>−</m:t>
+                              </m:r>
+                              <m:sSub>
+                                <m:sSubPr>
+                                  <m:ctrlPr>
+                                    <a:rPr lang="en-US" sz="2000" b="0" i="1" u="none" strike="noStrike" smtClean="0">
+                                      <a:solidFill>
+                                        <a:srgbClr val="000000"/>
+                                      </a:solidFill>
+                                      <a:effectLst/>
+                                      <a:uFillTx/>
+                                      <a:latin typeface="Cambria Math" panose="02040503050406030204" pitchFamily="18" charset="0"/>
+                                      <a:ea typeface="Cambria Math" panose="02040503050406030204" pitchFamily="18" charset="0"/>
+                                    </a:rPr>
+                                  </m:ctrlPr>
+                                </m:sSubPr>
+                                <m:e>
+                                  <m:r>
+                                    <a:rPr lang="en-US" sz="2000" b="0" i="1" u="none" strike="noStrike" smtClean="0">
+                                      <a:solidFill>
+                                        <a:srgbClr val="000000"/>
+                                      </a:solidFill>
+                                      <a:effectLst/>
+                                      <a:uFillTx/>
+                                      <a:latin typeface="Cambria Math" panose="02040503050406030204" pitchFamily="18" charset="0"/>
+                                      <a:ea typeface="Cambria Math" panose="02040503050406030204" pitchFamily="18" charset="0"/>
+                                    </a:rPr>
+                                    <m:t>𝑝</m:t>
+                                  </m:r>
+                                </m:e>
+                                <m:sub>
+                                  <m:r>
+                                    <a:rPr lang="en-US" sz="2000" b="0" i="1" u="none" strike="noStrike" smtClean="0">
+                                      <a:solidFill>
+                                        <a:srgbClr val="000000"/>
+                                      </a:solidFill>
+                                      <a:effectLst/>
+                                      <a:uFillTx/>
+                                      <a:latin typeface="Cambria Math" panose="02040503050406030204" pitchFamily="18" charset="0"/>
+                                      <a:ea typeface="Cambria Math" panose="02040503050406030204" pitchFamily="18" charset="0"/>
+                                    </a:rPr>
+                                    <m:t>𝑘</m:t>
+                                  </m:r>
+                                </m:sub>
+                              </m:sSub>
+                              <m:r>
+                                <a:rPr lang="en-US" sz="2000" b="0" i="1" u="none" strike="noStrike" smtClean="0">
+                                  <a:solidFill>
+                                    <a:srgbClr val="000000"/>
+                                  </a:solidFill>
+                                  <a:effectLst/>
+                                  <a:uFillTx/>
+                                  <a:latin typeface="Cambria Math" panose="02040503050406030204" pitchFamily="18" charset="0"/>
+                                  <a:ea typeface="Cambria Math" panose="02040503050406030204" pitchFamily="18" charset="0"/>
+                                </a:rPr>
+                                <m:t>|</m:t>
+                              </m:r>
+                            </m:e>
+                          </m:nary>
+                        </m:den>
+                      </m:f>
+                    </m:oMath>
+                  </m:oMathPara>
+                </a14:m>
+                <a:endParaRPr lang="en-US" sz="2000" b="0" u="none" strike="noStrike" dirty="0">
+                  <a:solidFill>
+                    <a:srgbClr val="000000"/>
+                  </a:solidFill>
+                  <a:effectLst/>
+                  <a:uFillTx/>
+                  <a:latin typeface="Arial"/>
+                </a:endParaRPr>
+              </a:p>
+            </p:txBody>
+          </p:sp>
+        </mc:Choice>
+        <mc:Fallback>
+          <p:sp>
+            <p:nvSpPr>
+              <p:cNvPr id="32" name="Text 5"/>
+              <p:cNvSpPr>
+                <a:spLocks noRot="1" noChangeAspect="1" noMove="1" noResize="1" noEditPoints="1" noAdjustHandles="1" noChangeArrowheads="1" noChangeShapeType="1" noTextEdit="1"/>
+              </p:cNvSpPr>
+              <p:nvPr/>
+            </p:nvSpPr>
+            <p:spPr>
+              <a:xfrm>
+                <a:off x="685800" y="1371600"/>
+                <a:ext cx="5577480" cy="914040"/>
+              </a:xfrm>
+              <a:prstGeom prst="rect">
+                <a:avLst/>
+              </a:prstGeom>
+              <a:blipFill>
+                <a:blip r:embed="rId3"/>
+                <a:stretch>
+                  <a:fillRect/>
+                </a:stretch>
+              </a:blipFill>
+              <a:ln w="12700">
+                <a:solidFill>
+                  <a:srgbClr val="D7E0EA"/>
+                </a:solidFill>
+                <a:round/>
+              </a:ln>
+            </p:spPr>
+            <p:txBody>
+              <a:bodyPr/>
+              <a:lstStyle/>
+              <a:p>
+                <a:r>
+                  <a:rPr lang="en-US">
+                    <a:noFill/>
+                  </a:rPr>
+                  <a:t> </a:t>
+                </a:r>
+              </a:p>
+            </p:txBody>
+          </p:sp>
+        </mc:Fallback>
+      </mc:AlternateContent>
       <p:pic>
         <p:nvPicPr>
           <p:cNvPr id="33" name="Image 0" descr="/mnt/data/week5_lectures9_10/assets/L9_pz_geometry.png"/>
@@ -15431,7 +16388,7 @@
           <p:nvPr/>
         </p:nvPicPr>
         <p:blipFill>
-          <a:blip r:embed="rId3"/>
+          <a:blip r:embed="rId4"/>
           <a:stretch/>
         </p:blipFill>
         <p:spPr>
@@ -15988,78 +16945,614 @@
           </a:p>
         </p:txBody>
       </p:sp>
-      <p:sp>
-        <p:nvSpPr>
-          <p:cNvPr id="42" name="Text 5"/>
-          <p:cNvSpPr/>
-          <p:nvPr/>
-        </p:nvSpPr>
-        <p:spPr>
-          <a:xfrm>
-            <a:off x="640080" y="1463040"/>
-            <a:ext cx="10881000" cy="914040"/>
-          </a:xfrm>
-          <a:prstGeom prst="rect">
-            <a:avLst/>
-          </a:prstGeom>
-          <a:solidFill>
-            <a:srgbClr val="F4F7FB"/>
-          </a:solidFill>
-          <a:ln w="12700">
-            <a:solidFill>
-              <a:srgbClr val="D7E0EA"/>
-            </a:solidFill>
-            <a:round/>
-          </a:ln>
-        </p:spPr>
-        <p:style>
-          <a:lnRef idx="0">
-            <a:scrgbClr r="0" g="0" b="0"/>
-          </a:lnRef>
-          <a:fillRef idx="0">
-            <a:scrgbClr r="0" g="0" b="0"/>
-          </a:fillRef>
-          <a:effectRef idx="0">
-            <a:scrgbClr r="0" g="0" b="0"/>
-          </a:effectRef>
-          <a:fontRef idx="minor"/>
-        </p:style>
-        <p:txBody>
-          <a:bodyPr lIns="360" tIns="360" rIns="360" bIns="360" anchor="ctr">
-            <a:noAutofit/>
-          </a:bodyPr>
-          <a:lstStyle/>
-          <a:p>
-            <a:pPr algn="ctr" defTabSz="914400">
-              <a:lnSpc>
-                <a:spcPct val="100000"/>
-              </a:lnSpc>
-              <a:tabLst>
-                <a:tab pos="0" algn="l"/>
-              </a:tabLst>
-            </a:pPr>
-            <a:r>
-              <a:rPr lang="en-US" sz="1800" b="1" u="none" strike="noStrike">
-                <a:solidFill>
-                  <a:srgbClr val="17365D"/>
-                </a:solidFill>
-                <a:effectLst/>
-                <a:uFillTx/>
-                <a:latin typeface="Aptos"/>
-              </a:rPr>
-              <a:t>$$\angle H(e^{j\omega})=\angle K+\sum_i\angle(e^{j\omega}-z_i)-\sum_k\angle(e^{j\omega}-p_k)$$</a:t>
-            </a:r>
-            <a:endParaRPr lang="en-US" sz="1800" b="0" u="none" strike="noStrike">
-              <a:solidFill>
-                <a:srgbClr val="000000"/>
-              </a:solidFill>
-              <a:effectLst/>
-              <a:uFillTx/>
-              <a:latin typeface="Arial"/>
-            </a:endParaRPr>
-          </a:p>
-        </p:txBody>
-      </p:sp>
+      <mc:AlternateContent xmlns:mc="http://schemas.openxmlformats.org/markup-compatibility/2006">
+        <mc:Choice xmlns:a14="http://schemas.microsoft.com/office/drawing/2010/main" Requires="a14">
+          <p:sp>
+            <p:nvSpPr>
+              <p:cNvPr id="42" name="Text 5"/>
+              <p:cNvSpPr/>
+              <p:nvPr/>
+            </p:nvSpPr>
+            <p:spPr>
+              <a:xfrm>
+                <a:off x="640080" y="1463040"/>
+                <a:ext cx="10881000" cy="914040"/>
+              </a:xfrm>
+              <a:prstGeom prst="rect">
+                <a:avLst/>
+              </a:prstGeom>
+              <a:solidFill>
+                <a:srgbClr val="F4F7FB"/>
+              </a:solidFill>
+              <a:ln w="12700">
+                <a:solidFill>
+                  <a:srgbClr val="D7E0EA"/>
+                </a:solidFill>
+                <a:round/>
+              </a:ln>
+            </p:spPr>
+            <p:style>
+              <a:lnRef idx="0">
+                <a:scrgbClr r="0" g="0" b="0"/>
+              </a:lnRef>
+              <a:fillRef idx="0">
+                <a:scrgbClr r="0" g="0" b="0"/>
+              </a:fillRef>
+              <a:effectRef idx="0">
+                <a:scrgbClr r="0" g="0" b="0"/>
+              </a:effectRef>
+              <a:fontRef idx="minor"/>
+            </p:style>
+            <p:txBody>
+              <a:bodyPr lIns="360" tIns="360" rIns="360" bIns="360" anchor="ctr">
+                <a:noAutofit/>
+              </a:bodyPr>
+              <a:lstStyle/>
+              <a:p>
+                <a:pPr algn="ctr" defTabSz="914400">
+                  <a:lnSpc>
+                    <a:spcPct val="100000"/>
+                  </a:lnSpc>
+                  <a:tabLst>
+                    <a:tab pos="0" algn="l"/>
+                  </a:tabLst>
+                </a:pPr>
+                <a14:m>
+                  <m:oMathPara xmlns:m="http://schemas.openxmlformats.org/officeDocument/2006/math">
+                    <m:oMath>
+                      <m:r>
+                        <a:rPr lang="en-US" sz="1800" b="0" i="1" u="none" strike="noStrike" smtClean="0">
+                          <a:solidFill>
+                            <a:srgbClr val="000000"/>
+                          </a:solidFill>
+                          <a:effectLst/>
+                          <a:uFillTx/>
+                          <a:latin typeface="Cambria Math" panose="02040503050406030204" pitchFamily="18" charset="0"/>
+                          <a:ea typeface="Cambria Math" panose="02040503050406030204" pitchFamily="18" charset="0"/>
+                        </a:rPr>
+                        <m:t>∠</m:t>
+                      </m:r>
+                      <m:r>
+                        <a:rPr lang="en-US" sz="1800" b="0" i="1" u="none" strike="noStrike" smtClean="0">
+                          <a:solidFill>
+                            <a:srgbClr val="000000"/>
+                          </a:solidFill>
+                          <a:effectLst/>
+                          <a:uFillTx/>
+                          <a:latin typeface="Cambria Math" panose="02040503050406030204" pitchFamily="18" charset="0"/>
+                          <a:ea typeface="Cambria Math" panose="02040503050406030204" pitchFamily="18" charset="0"/>
+                        </a:rPr>
+                        <m:t>𝐻</m:t>
+                      </m:r>
+                      <m:d>
+                        <m:dPr>
+                          <m:ctrlPr>
+                            <a:rPr lang="en-US" sz="1800" b="0" i="1" u="none" strike="noStrike" smtClean="0">
+                              <a:solidFill>
+                                <a:srgbClr val="000000"/>
+                              </a:solidFill>
+                              <a:effectLst/>
+                              <a:uFillTx/>
+                              <a:latin typeface="Cambria Math" panose="02040503050406030204" pitchFamily="18" charset="0"/>
+                              <a:ea typeface="Cambria Math" panose="02040503050406030204" pitchFamily="18" charset="0"/>
+                            </a:rPr>
+                          </m:ctrlPr>
+                        </m:dPr>
+                        <m:e>
+                          <m:sSup>
+                            <m:sSupPr>
+                              <m:ctrlPr>
+                                <a:rPr lang="en-US" sz="1800" b="0" i="1" u="none" strike="noStrike" smtClean="0">
+                                  <a:solidFill>
+                                    <a:srgbClr val="000000"/>
+                                  </a:solidFill>
+                                  <a:effectLst/>
+                                  <a:uFillTx/>
+                                  <a:latin typeface="Cambria Math" panose="02040503050406030204" pitchFamily="18" charset="0"/>
+                                  <a:ea typeface="Cambria Math" panose="02040503050406030204" pitchFamily="18" charset="0"/>
+                                </a:rPr>
+                              </m:ctrlPr>
+                            </m:sSupPr>
+                            <m:e>
+                              <m:r>
+                                <a:rPr lang="en-US" sz="1800" b="0" i="1" u="none" strike="noStrike" smtClean="0">
+                                  <a:solidFill>
+                                    <a:srgbClr val="000000"/>
+                                  </a:solidFill>
+                                  <a:effectLst/>
+                                  <a:uFillTx/>
+                                  <a:latin typeface="Cambria Math" panose="02040503050406030204" pitchFamily="18" charset="0"/>
+                                  <a:ea typeface="Cambria Math" panose="02040503050406030204" pitchFamily="18" charset="0"/>
+                                </a:rPr>
+                                <m:t>𝑒</m:t>
+                              </m:r>
+                            </m:e>
+                            <m:sup>
+                              <m:r>
+                                <a:rPr lang="en-US" sz="1800" b="0" i="1" u="none" strike="noStrike" smtClean="0">
+                                  <a:solidFill>
+                                    <a:srgbClr val="000000"/>
+                                  </a:solidFill>
+                                  <a:effectLst/>
+                                  <a:uFillTx/>
+                                  <a:latin typeface="Cambria Math" panose="02040503050406030204" pitchFamily="18" charset="0"/>
+                                  <a:ea typeface="Cambria Math" panose="02040503050406030204" pitchFamily="18" charset="0"/>
+                                </a:rPr>
+                                <m:t>𝑗</m:t>
+                              </m:r>
+                              <m:r>
+                                <a:rPr lang="en-US" sz="1800" b="0" i="1" u="none" strike="noStrike" smtClean="0">
+                                  <a:solidFill>
+                                    <a:srgbClr val="000000"/>
+                                  </a:solidFill>
+                                  <a:effectLst/>
+                                  <a:uFillTx/>
+                                  <a:latin typeface="Cambria Math" panose="02040503050406030204" pitchFamily="18" charset="0"/>
+                                  <a:ea typeface="Cambria Math" panose="02040503050406030204" pitchFamily="18" charset="0"/>
+                                </a:rPr>
+                                <m:t>𝜔</m:t>
+                              </m:r>
+                            </m:sup>
+                          </m:sSup>
+                        </m:e>
+                      </m:d>
+                      <m:r>
+                        <a:rPr lang="en-US" sz="1800" b="0" i="1" u="none" strike="noStrike" smtClean="0">
+                          <a:solidFill>
+                            <a:srgbClr val="000000"/>
+                          </a:solidFill>
+                          <a:effectLst/>
+                          <a:uFillTx/>
+                          <a:latin typeface="Cambria Math" panose="02040503050406030204" pitchFamily="18" charset="0"/>
+                          <a:ea typeface="Cambria Math" panose="02040503050406030204" pitchFamily="18" charset="0"/>
+                        </a:rPr>
+                        <m:t>=∠</m:t>
+                      </m:r>
+                      <m:r>
+                        <a:rPr lang="en-US" sz="1800" b="0" i="1" u="none" strike="noStrike" smtClean="0">
+                          <a:solidFill>
+                            <a:srgbClr val="000000"/>
+                          </a:solidFill>
+                          <a:effectLst/>
+                          <a:uFillTx/>
+                          <a:latin typeface="Cambria Math" panose="02040503050406030204" pitchFamily="18" charset="0"/>
+                          <a:ea typeface="Cambria Math" panose="02040503050406030204" pitchFamily="18" charset="0"/>
+                        </a:rPr>
+                        <m:t>𝐾</m:t>
+                      </m:r>
+                      <m:r>
+                        <a:rPr lang="en-US" sz="1800" b="0" i="1" u="none" strike="noStrike" smtClean="0">
+                          <a:solidFill>
+                            <a:srgbClr val="000000"/>
+                          </a:solidFill>
+                          <a:effectLst/>
+                          <a:uFillTx/>
+                          <a:latin typeface="Cambria Math" panose="02040503050406030204" pitchFamily="18" charset="0"/>
+                          <a:ea typeface="Cambria Math" panose="02040503050406030204" pitchFamily="18" charset="0"/>
+                        </a:rPr>
+                        <m:t>+</m:t>
+                      </m:r>
+                      <m:nary>
+                        <m:naryPr>
+                          <m:chr m:val="∑"/>
+                          <m:limLoc m:val="subSup"/>
+                          <m:supHide m:val="on"/>
+                          <m:ctrlPr>
+                            <a:rPr lang="en-US" sz="1800" b="0" i="1" u="none" strike="noStrike" smtClean="0">
+                              <a:solidFill>
+                                <a:srgbClr val="000000"/>
+                              </a:solidFill>
+                              <a:effectLst/>
+                              <a:uFillTx/>
+                              <a:latin typeface="Cambria Math" panose="02040503050406030204" pitchFamily="18" charset="0"/>
+                              <a:ea typeface="Cambria Math" panose="02040503050406030204" pitchFamily="18" charset="0"/>
+                            </a:rPr>
+                          </m:ctrlPr>
+                        </m:naryPr>
+                        <m:sub>
+                          <m:r>
+                            <m:rPr>
+                              <m:brk m:alnAt="9"/>
+                            </m:rPr>
+                            <a:rPr lang="en-US" sz="1800" b="0" i="1" u="none" strike="noStrike" smtClean="0">
+                              <a:solidFill>
+                                <a:srgbClr val="000000"/>
+                              </a:solidFill>
+                              <a:effectLst/>
+                              <a:uFillTx/>
+                              <a:latin typeface="Cambria Math" panose="02040503050406030204" pitchFamily="18" charset="0"/>
+                              <a:ea typeface="Cambria Math" panose="02040503050406030204" pitchFamily="18" charset="0"/>
+                            </a:rPr>
+                            <m:t>𝑖</m:t>
+                          </m:r>
+                        </m:sub>
+                        <m:sup/>
+                        <m:e>
+                          <m:r>
+                            <a:rPr lang="en-US" sz="1800" b="0" i="1" u="none" strike="noStrike" smtClean="0">
+                              <a:solidFill>
+                                <a:srgbClr val="000000"/>
+                              </a:solidFill>
+                              <a:effectLst/>
+                              <a:uFillTx/>
+                              <a:latin typeface="Cambria Math" panose="02040503050406030204" pitchFamily="18" charset="0"/>
+                              <a:ea typeface="Cambria Math" panose="02040503050406030204" pitchFamily="18" charset="0"/>
+                            </a:rPr>
+                            <m:t>∠</m:t>
+                          </m:r>
+                          <m:d>
+                            <m:dPr>
+                              <m:ctrlPr>
+                                <a:rPr lang="en-US" sz="1800" b="0" i="1" u="none" strike="noStrike" smtClean="0">
+                                  <a:solidFill>
+                                    <a:srgbClr val="000000"/>
+                                  </a:solidFill>
+                                  <a:effectLst/>
+                                  <a:uFillTx/>
+                                  <a:latin typeface="Cambria Math" panose="02040503050406030204" pitchFamily="18" charset="0"/>
+                                  <a:ea typeface="Cambria Math" panose="02040503050406030204" pitchFamily="18" charset="0"/>
+                                </a:rPr>
+                              </m:ctrlPr>
+                            </m:dPr>
+                            <m:e>
+                              <m:sSup>
+                                <m:sSupPr>
+                                  <m:ctrlPr>
+                                    <a:rPr lang="en-US" sz="1800" b="0" i="1" u="none" strike="noStrike" smtClean="0">
+                                      <a:solidFill>
+                                        <a:srgbClr val="000000"/>
+                                      </a:solidFill>
+                                      <a:effectLst/>
+                                      <a:uFillTx/>
+                                      <a:latin typeface="Cambria Math" panose="02040503050406030204" pitchFamily="18" charset="0"/>
+                                      <a:ea typeface="Cambria Math" panose="02040503050406030204" pitchFamily="18" charset="0"/>
+                                    </a:rPr>
+                                  </m:ctrlPr>
+                                </m:sSupPr>
+                                <m:e>
+                                  <m:r>
+                                    <a:rPr lang="en-US" sz="1800" b="0" i="1" u="none" strike="noStrike" smtClean="0">
+                                      <a:solidFill>
+                                        <a:srgbClr val="000000"/>
+                                      </a:solidFill>
+                                      <a:effectLst/>
+                                      <a:uFillTx/>
+                                      <a:latin typeface="Cambria Math" panose="02040503050406030204" pitchFamily="18" charset="0"/>
+                                      <a:ea typeface="Cambria Math" panose="02040503050406030204" pitchFamily="18" charset="0"/>
+                                    </a:rPr>
+                                    <m:t>𝑒</m:t>
+                                  </m:r>
+                                </m:e>
+                                <m:sup>
+                                  <m:r>
+                                    <a:rPr lang="en-US" sz="1800" b="0" i="1" u="none" strike="noStrike" smtClean="0">
+                                      <a:solidFill>
+                                        <a:srgbClr val="000000"/>
+                                      </a:solidFill>
+                                      <a:effectLst/>
+                                      <a:uFillTx/>
+                                      <a:latin typeface="Cambria Math" panose="02040503050406030204" pitchFamily="18" charset="0"/>
+                                      <a:ea typeface="Cambria Math" panose="02040503050406030204" pitchFamily="18" charset="0"/>
+                                    </a:rPr>
+                                    <m:t>𝑗</m:t>
+                                  </m:r>
+                                  <m:r>
+                                    <a:rPr lang="en-US" sz="1800" b="0" i="1" u="none" strike="noStrike" smtClean="0">
+                                      <a:solidFill>
+                                        <a:srgbClr val="000000"/>
+                                      </a:solidFill>
+                                      <a:effectLst/>
+                                      <a:uFillTx/>
+                                      <a:latin typeface="Cambria Math" panose="02040503050406030204" pitchFamily="18" charset="0"/>
+                                      <a:ea typeface="Cambria Math" panose="02040503050406030204" pitchFamily="18" charset="0"/>
+                                    </a:rPr>
+                                    <m:t>𝜔</m:t>
+                                  </m:r>
+                                </m:sup>
+                              </m:sSup>
+                              <m:r>
+                                <a:rPr lang="en-US" sz="1800" b="0" i="1" u="none" strike="noStrike" smtClean="0">
+                                  <a:solidFill>
+                                    <a:srgbClr val="000000"/>
+                                  </a:solidFill>
+                                  <a:effectLst/>
+                                  <a:uFillTx/>
+                                  <a:latin typeface="Cambria Math" panose="02040503050406030204" pitchFamily="18" charset="0"/>
+                                  <a:ea typeface="Cambria Math" panose="02040503050406030204" pitchFamily="18" charset="0"/>
+                                </a:rPr>
+                                <m:t>−</m:t>
+                              </m:r>
+                              <m:sSub>
+                                <m:sSubPr>
+                                  <m:ctrlPr>
+                                    <a:rPr lang="en-US" sz="1800" b="0" i="1" u="none" strike="noStrike" smtClean="0">
+                                      <a:solidFill>
+                                        <a:srgbClr val="000000"/>
+                                      </a:solidFill>
+                                      <a:effectLst/>
+                                      <a:uFillTx/>
+                                      <a:latin typeface="Cambria Math" panose="02040503050406030204" pitchFamily="18" charset="0"/>
+                                      <a:ea typeface="Cambria Math" panose="02040503050406030204" pitchFamily="18" charset="0"/>
+                                    </a:rPr>
+                                  </m:ctrlPr>
+                                </m:sSubPr>
+                                <m:e>
+                                  <m:r>
+                                    <a:rPr lang="en-US" sz="1800" b="0" i="1" u="none" strike="noStrike" smtClean="0">
+                                      <a:solidFill>
+                                        <a:srgbClr val="000000"/>
+                                      </a:solidFill>
+                                      <a:effectLst/>
+                                      <a:uFillTx/>
+                                      <a:latin typeface="Cambria Math" panose="02040503050406030204" pitchFamily="18" charset="0"/>
+                                      <a:ea typeface="Cambria Math" panose="02040503050406030204" pitchFamily="18" charset="0"/>
+                                    </a:rPr>
+                                    <m:t>𝑧</m:t>
+                                  </m:r>
+                                </m:e>
+                                <m:sub>
+                                  <m:r>
+                                    <a:rPr lang="en-US" sz="1800" b="0" i="1" u="none" strike="noStrike" smtClean="0">
+                                      <a:solidFill>
+                                        <a:srgbClr val="000000"/>
+                                      </a:solidFill>
+                                      <a:effectLst/>
+                                      <a:uFillTx/>
+                                      <a:latin typeface="Cambria Math" panose="02040503050406030204" pitchFamily="18" charset="0"/>
+                                      <a:ea typeface="Cambria Math" panose="02040503050406030204" pitchFamily="18" charset="0"/>
+                                    </a:rPr>
+                                    <m:t>𝑖</m:t>
+                                  </m:r>
+                                </m:sub>
+                              </m:sSub>
+                            </m:e>
+                          </m:d>
+                          <m:r>
+                            <a:rPr lang="en-US" sz="1800" b="0" i="1" u="none" strike="noStrike" smtClean="0">
+                              <a:solidFill>
+                                <a:srgbClr val="000000"/>
+                              </a:solidFill>
+                              <a:effectLst/>
+                              <a:uFillTx/>
+                              <a:latin typeface="Cambria Math" panose="02040503050406030204" pitchFamily="18" charset="0"/>
+                              <a:ea typeface="Cambria Math" panose="02040503050406030204" pitchFamily="18" charset="0"/>
+                            </a:rPr>
+                            <m:t>−</m:t>
+                          </m:r>
+                          <m:nary>
+                            <m:naryPr>
+                              <m:chr m:val="∑"/>
+                              <m:limLoc m:val="subSup"/>
+                              <m:supHide m:val="on"/>
+                              <m:ctrlPr>
+                                <a:rPr lang="en-US" sz="1800" b="0" i="1" u="none" strike="noStrike" smtClean="0">
+                                  <a:solidFill>
+                                    <a:srgbClr val="000000"/>
+                                  </a:solidFill>
+                                  <a:effectLst/>
+                                  <a:uFillTx/>
+                                  <a:latin typeface="Cambria Math" panose="02040503050406030204" pitchFamily="18" charset="0"/>
+                                  <a:ea typeface="Cambria Math" panose="02040503050406030204" pitchFamily="18" charset="0"/>
+                                </a:rPr>
+                              </m:ctrlPr>
+                            </m:naryPr>
+                            <m:sub>
+                              <m:r>
+                                <m:rPr>
+                                  <m:brk m:alnAt="9"/>
+                                </m:rPr>
+                                <a:rPr lang="en-US" sz="1800" b="0" i="1" u="none" strike="noStrike" smtClean="0">
+                                  <a:solidFill>
+                                    <a:srgbClr val="000000"/>
+                                  </a:solidFill>
+                                  <a:effectLst/>
+                                  <a:uFillTx/>
+                                  <a:latin typeface="Cambria Math" panose="02040503050406030204" pitchFamily="18" charset="0"/>
+                                  <a:ea typeface="Cambria Math" panose="02040503050406030204" pitchFamily="18" charset="0"/>
+                                </a:rPr>
+                                <m:t>𝑘</m:t>
+                              </m:r>
+                            </m:sub>
+                            <m:sup/>
+                            <m:e>
+                              <m:r>
+                                <a:rPr lang="en-US" sz="1800" b="0" i="1" u="none" strike="noStrike" smtClean="0">
+                                  <a:solidFill>
+                                    <a:srgbClr val="000000"/>
+                                  </a:solidFill>
+                                  <a:effectLst/>
+                                  <a:uFillTx/>
+                                  <a:latin typeface="Cambria Math" panose="02040503050406030204" pitchFamily="18" charset="0"/>
+                                  <a:ea typeface="Cambria Math" panose="02040503050406030204" pitchFamily="18" charset="0"/>
+                                </a:rPr>
+                                <m:t>∠(</m:t>
+                              </m:r>
+                              <m:sSup>
+                                <m:sSupPr>
+                                  <m:ctrlPr>
+                                    <a:rPr lang="en-US" sz="1800" b="0" i="1" u="none" strike="noStrike" smtClean="0">
+                                      <a:solidFill>
+                                        <a:srgbClr val="000000"/>
+                                      </a:solidFill>
+                                      <a:effectLst/>
+                                      <a:uFillTx/>
+                                      <a:latin typeface="Cambria Math" panose="02040503050406030204" pitchFamily="18" charset="0"/>
+                                      <a:ea typeface="Cambria Math" panose="02040503050406030204" pitchFamily="18" charset="0"/>
+                                    </a:rPr>
+                                  </m:ctrlPr>
+                                </m:sSupPr>
+                                <m:e>
+                                  <m:r>
+                                    <a:rPr lang="en-US" sz="1800" b="0" i="1" u="none" strike="noStrike" smtClean="0">
+                                      <a:solidFill>
+                                        <a:srgbClr val="000000"/>
+                                      </a:solidFill>
+                                      <a:effectLst/>
+                                      <a:uFillTx/>
+                                      <a:latin typeface="Cambria Math" panose="02040503050406030204" pitchFamily="18" charset="0"/>
+                                      <a:ea typeface="Cambria Math" panose="02040503050406030204" pitchFamily="18" charset="0"/>
+                                    </a:rPr>
+                                    <m:t>𝑒</m:t>
+                                  </m:r>
+                                </m:e>
+                                <m:sup>
+                                  <m:r>
+                                    <a:rPr lang="en-US" sz="1800" b="0" i="1" u="none" strike="noStrike" smtClean="0">
+                                      <a:solidFill>
+                                        <a:srgbClr val="000000"/>
+                                      </a:solidFill>
+                                      <a:effectLst/>
+                                      <a:uFillTx/>
+                                      <a:latin typeface="Cambria Math" panose="02040503050406030204" pitchFamily="18" charset="0"/>
+                                      <a:ea typeface="Cambria Math" panose="02040503050406030204" pitchFamily="18" charset="0"/>
+                                    </a:rPr>
+                                    <m:t>𝑗</m:t>
+                                  </m:r>
+                                  <m:r>
+                                    <a:rPr lang="en-US" sz="1800" b="0" i="1" u="none" strike="noStrike" smtClean="0">
+                                      <a:solidFill>
+                                        <a:srgbClr val="000000"/>
+                                      </a:solidFill>
+                                      <a:effectLst/>
+                                      <a:uFillTx/>
+                                      <a:latin typeface="Cambria Math" panose="02040503050406030204" pitchFamily="18" charset="0"/>
+                                      <a:ea typeface="Cambria Math" panose="02040503050406030204" pitchFamily="18" charset="0"/>
+                                    </a:rPr>
+                                    <m:t>𝜔</m:t>
+                                  </m:r>
+                                </m:sup>
+                              </m:sSup>
+                              <m:r>
+                                <a:rPr lang="en-US" sz="1800" b="0" i="1" u="none" strike="noStrike" smtClean="0">
+                                  <a:solidFill>
+                                    <a:srgbClr val="000000"/>
+                                  </a:solidFill>
+                                  <a:effectLst/>
+                                  <a:uFillTx/>
+                                  <a:latin typeface="Cambria Math" panose="02040503050406030204" pitchFamily="18" charset="0"/>
+                                  <a:ea typeface="Cambria Math" panose="02040503050406030204" pitchFamily="18" charset="0"/>
+                                </a:rPr>
+                                <m:t>−</m:t>
+                              </m:r>
+                              <m:sSub>
+                                <m:sSubPr>
+                                  <m:ctrlPr>
+                                    <a:rPr lang="en-US" sz="1800" b="0" i="1" u="none" strike="noStrike" smtClean="0">
+                                      <a:solidFill>
+                                        <a:srgbClr val="000000"/>
+                                      </a:solidFill>
+                                      <a:effectLst/>
+                                      <a:uFillTx/>
+                                      <a:latin typeface="Cambria Math" panose="02040503050406030204" pitchFamily="18" charset="0"/>
+                                      <a:ea typeface="Cambria Math" panose="02040503050406030204" pitchFamily="18" charset="0"/>
+                                    </a:rPr>
+                                  </m:ctrlPr>
+                                </m:sSubPr>
+                                <m:e>
+                                  <m:r>
+                                    <a:rPr lang="en-US" sz="1800" b="0" i="1" u="none" strike="noStrike" smtClean="0">
+                                      <a:solidFill>
+                                        <a:srgbClr val="000000"/>
+                                      </a:solidFill>
+                                      <a:effectLst/>
+                                      <a:uFillTx/>
+                                      <a:latin typeface="Cambria Math" panose="02040503050406030204" pitchFamily="18" charset="0"/>
+                                      <a:ea typeface="Cambria Math" panose="02040503050406030204" pitchFamily="18" charset="0"/>
+                                    </a:rPr>
+                                    <m:t>𝑝</m:t>
+                                  </m:r>
+                                </m:e>
+                                <m:sub>
+                                  <m:r>
+                                    <a:rPr lang="en-US" sz="1800" b="0" i="1" u="none" strike="noStrike" smtClean="0">
+                                      <a:solidFill>
+                                        <a:srgbClr val="000000"/>
+                                      </a:solidFill>
+                                      <a:effectLst/>
+                                      <a:uFillTx/>
+                                      <a:latin typeface="Cambria Math" panose="02040503050406030204" pitchFamily="18" charset="0"/>
+                                      <a:ea typeface="Cambria Math" panose="02040503050406030204" pitchFamily="18" charset="0"/>
+                                    </a:rPr>
+                                    <m:t>𝑘</m:t>
+                                  </m:r>
+                                </m:sub>
+                              </m:sSub>
+                              <m:r>
+                                <a:rPr lang="en-US" sz="1800" b="0" i="1" u="none" strike="noStrike" smtClean="0">
+                                  <a:solidFill>
+                                    <a:srgbClr val="000000"/>
+                                  </a:solidFill>
+                                  <a:effectLst/>
+                                  <a:uFillTx/>
+                                  <a:latin typeface="Cambria Math" panose="02040503050406030204" pitchFamily="18" charset="0"/>
+                                  <a:ea typeface="Cambria Math" panose="02040503050406030204" pitchFamily="18" charset="0"/>
+                                </a:rPr>
+                                <m:t>)</m:t>
+                              </m:r>
+                            </m:e>
+                          </m:nary>
+                        </m:e>
+                      </m:nary>
+                    </m:oMath>
+                  </m:oMathPara>
+                </a14:m>
+                <a:endParaRPr lang="en-US" sz="1800" b="0" u="none" strike="noStrike" dirty="0">
+                  <a:solidFill>
+                    <a:srgbClr val="000000"/>
+                  </a:solidFill>
+                  <a:effectLst/>
+                  <a:uFillTx/>
+                  <a:latin typeface="Arial"/>
+                </a:endParaRPr>
+              </a:p>
+            </p:txBody>
+          </p:sp>
+        </mc:Choice>
+        <mc:Fallback>
+          <p:sp>
+            <p:nvSpPr>
+              <p:cNvPr id="42" name="Text 5"/>
+              <p:cNvSpPr>
+                <a:spLocks noRot="1" noChangeAspect="1" noMove="1" noResize="1" noEditPoints="1" noAdjustHandles="1" noChangeArrowheads="1" noChangeShapeType="1" noTextEdit="1"/>
+              </p:cNvSpPr>
+              <p:nvPr/>
+            </p:nvSpPr>
+            <p:spPr>
+              <a:xfrm>
+                <a:off x="640080" y="1463040"/>
+                <a:ext cx="10881000" cy="914040"/>
+              </a:xfrm>
+              <a:prstGeom prst="rect">
+                <a:avLst/>
+              </a:prstGeom>
+              <a:blipFill>
+                <a:blip r:embed="rId3"/>
+                <a:stretch>
+                  <a:fillRect/>
+                </a:stretch>
+              </a:blipFill>
+              <a:ln w="12700">
+                <a:solidFill>
+                  <a:srgbClr val="D7E0EA"/>
+                </a:solidFill>
+                <a:round/>
+              </a:ln>
+            </p:spPr>
+            <p:txBody>
+              <a:bodyPr/>
+              <a:lstStyle/>
+              <a:p>
+                <a:r>
+                  <a:rPr lang="en-US">
+                    <a:noFill/>
+                  </a:rPr>
+                  <a:t> </a:t>
+                </a:r>
+              </a:p>
+            </p:txBody>
+          </p:sp>
+        </mc:Fallback>
+      </mc:AlternateContent>
       <p:sp>
         <p:nvSpPr>
           <p:cNvPr id="43" name="Text 6"/>
@@ -16542,78 +18035,290 @@
           </a:p>
         </p:txBody>
       </p:sp>
-      <p:sp>
-        <p:nvSpPr>
-          <p:cNvPr id="49" name="Text 5"/>
-          <p:cNvSpPr/>
-          <p:nvPr/>
-        </p:nvSpPr>
-        <p:spPr>
-          <a:xfrm>
-            <a:off x="731520" y="1371600"/>
-            <a:ext cx="5303160" cy="685440"/>
-          </a:xfrm>
-          <a:prstGeom prst="rect">
-            <a:avLst/>
-          </a:prstGeom>
-          <a:solidFill>
-            <a:srgbClr val="F4F7FB"/>
-          </a:solidFill>
-          <a:ln w="12700">
-            <a:solidFill>
-              <a:srgbClr val="D7E0EA"/>
-            </a:solidFill>
-            <a:round/>
-          </a:ln>
-        </p:spPr>
-        <p:style>
-          <a:lnRef idx="0">
-            <a:scrgbClr r="0" g="0" b="0"/>
-          </a:lnRef>
-          <a:fillRef idx="0">
-            <a:scrgbClr r="0" g="0" b="0"/>
-          </a:fillRef>
-          <a:effectRef idx="0">
-            <a:scrgbClr r="0" g="0" b="0"/>
-          </a:effectRef>
-          <a:fontRef idx="minor"/>
-        </p:style>
-        <p:txBody>
-          <a:bodyPr lIns="360" tIns="360" rIns="360" bIns="360" anchor="ctr">
-            <a:noAutofit/>
-          </a:bodyPr>
-          <a:lstStyle/>
-          <a:p>
-            <a:pPr algn="ctr" defTabSz="914400">
-              <a:lnSpc>
-                <a:spcPct val="100000"/>
-              </a:lnSpc>
-              <a:tabLst>
-                <a:tab pos="0" algn="l"/>
-              </a:tabLst>
-            </a:pPr>
-            <a:r>
-              <a:rPr lang="en-US" sz="2300" b="1" u="none" strike="noStrike">
-                <a:solidFill>
-                  <a:srgbClr val="17365D"/>
-                </a:solidFill>
-                <a:effectLst/>
-                <a:uFillTx/>
-                <a:latin typeface="Aptos"/>
-              </a:rPr>
-              <a:t>$$H(z)=\frac{1-0.8z^{-1}}{1-0.5z^{-1}}$$</a:t>
-            </a:r>
-            <a:endParaRPr lang="en-US" sz="2300" b="0" u="none" strike="noStrike">
-              <a:solidFill>
-                <a:srgbClr val="000000"/>
-              </a:solidFill>
-              <a:effectLst/>
-              <a:uFillTx/>
-              <a:latin typeface="Arial"/>
-            </a:endParaRPr>
-          </a:p>
-        </p:txBody>
-      </p:sp>
+      <mc:AlternateContent xmlns:mc="http://schemas.openxmlformats.org/markup-compatibility/2006">
+        <mc:Choice xmlns:a14="http://schemas.microsoft.com/office/drawing/2010/main" Requires="a14">
+          <p:sp>
+            <p:nvSpPr>
+              <p:cNvPr id="49" name="Text 5"/>
+              <p:cNvSpPr/>
+              <p:nvPr/>
+            </p:nvSpPr>
+            <p:spPr>
+              <a:xfrm>
+                <a:off x="731520" y="1234800"/>
+                <a:ext cx="5303160" cy="948030"/>
+              </a:xfrm>
+              <a:prstGeom prst="rect">
+                <a:avLst/>
+              </a:prstGeom>
+              <a:solidFill>
+                <a:srgbClr val="F4F7FB"/>
+              </a:solidFill>
+              <a:ln w="12700">
+                <a:solidFill>
+                  <a:srgbClr val="D7E0EA"/>
+                </a:solidFill>
+                <a:round/>
+              </a:ln>
+            </p:spPr>
+            <p:style>
+              <a:lnRef idx="0">
+                <a:scrgbClr r="0" g="0" b="0"/>
+              </a:lnRef>
+              <a:fillRef idx="0">
+                <a:scrgbClr r="0" g="0" b="0"/>
+              </a:fillRef>
+              <a:effectRef idx="0">
+                <a:scrgbClr r="0" g="0" b="0"/>
+              </a:effectRef>
+              <a:fontRef idx="minor"/>
+            </p:style>
+            <p:txBody>
+              <a:bodyPr lIns="360" tIns="360" rIns="360" bIns="360" anchor="ctr">
+                <a:noAutofit/>
+              </a:bodyPr>
+              <a:lstStyle/>
+              <a:p>
+                <a:pPr algn="ctr" defTabSz="914400">
+                  <a:lnSpc>
+                    <a:spcPct val="100000"/>
+                  </a:lnSpc>
+                  <a:tabLst>
+                    <a:tab pos="0" algn="l"/>
+                  </a:tabLst>
+                </a:pPr>
+                <a14:m>
+                  <m:oMathPara xmlns:m="http://schemas.openxmlformats.org/officeDocument/2006/math">
+                    <m:oMath>
+                      <m:r>
+                        <a:rPr lang="en-US" sz="2300" b="0" i="1" u="none" strike="noStrike" smtClean="0">
+                          <a:solidFill>
+                            <a:srgbClr val="000000"/>
+                          </a:solidFill>
+                          <a:effectLst/>
+                          <a:uFillTx/>
+                          <a:latin typeface="Cambria Math" panose="02040503050406030204" pitchFamily="18" charset="0"/>
+                        </a:rPr>
+                        <m:t>𝐻</m:t>
+                      </m:r>
+                      <m:d>
+                        <m:dPr>
+                          <m:ctrlPr>
+                            <a:rPr lang="en-US" sz="2300" b="0" i="1" u="none" strike="noStrike" smtClean="0">
+                              <a:solidFill>
+                                <a:srgbClr val="000000"/>
+                              </a:solidFill>
+                              <a:effectLst/>
+                              <a:uFillTx/>
+                              <a:latin typeface="Cambria Math" panose="02040503050406030204" pitchFamily="18" charset="0"/>
+                            </a:rPr>
+                          </m:ctrlPr>
+                        </m:dPr>
+                        <m:e>
+                          <m:r>
+                            <a:rPr lang="en-US" sz="2300" b="0" i="1" u="none" strike="noStrike" smtClean="0">
+                              <a:solidFill>
+                                <a:srgbClr val="000000"/>
+                              </a:solidFill>
+                              <a:effectLst/>
+                              <a:uFillTx/>
+                              <a:latin typeface="Cambria Math" panose="02040503050406030204" pitchFamily="18" charset="0"/>
+                            </a:rPr>
+                            <m:t>𝑧</m:t>
+                          </m:r>
+                        </m:e>
+                      </m:d>
+                      <m:r>
+                        <a:rPr lang="en-US" sz="2300" b="0" i="1" u="none" strike="noStrike" smtClean="0">
+                          <a:solidFill>
+                            <a:srgbClr val="000000"/>
+                          </a:solidFill>
+                          <a:effectLst/>
+                          <a:uFillTx/>
+                          <a:latin typeface="Cambria Math" panose="02040503050406030204" pitchFamily="18" charset="0"/>
+                        </a:rPr>
+                        <m:t>=</m:t>
+                      </m:r>
+                      <m:f>
+                        <m:fPr>
+                          <m:ctrlPr>
+                            <a:rPr lang="en-US" sz="2300" b="0" i="1" u="none" strike="noStrike" smtClean="0">
+                              <a:solidFill>
+                                <a:srgbClr val="000000"/>
+                              </a:solidFill>
+                              <a:effectLst/>
+                              <a:uFillTx/>
+                              <a:latin typeface="Cambria Math" panose="02040503050406030204" pitchFamily="18" charset="0"/>
+                            </a:rPr>
+                          </m:ctrlPr>
+                        </m:fPr>
+                        <m:num>
+                          <m:r>
+                            <a:rPr lang="en-US" sz="2300" b="0" i="1" u="none" strike="noStrike" smtClean="0">
+                              <a:solidFill>
+                                <a:srgbClr val="000000"/>
+                              </a:solidFill>
+                              <a:effectLst/>
+                              <a:uFillTx/>
+                              <a:latin typeface="Cambria Math" panose="02040503050406030204" pitchFamily="18" charset="0"/>
+                            </a:rPr>
+                            <m:t>1−0.8</m:t>
+                          </m:r>
+                          <m:sSup>
+                            <m:sSupPr>
+                              <m:ctrlPr>
+                                <a:rPr lang="en-US" sz="2300" b="0" i="1" u="none" strike="noStrike" smtClean="0">
+                                  <a:solidFill>
+                                    <a:srgbClr val="000000"/>
+                                  </a:solidFill>
+                                  <a:effectLst/>
+                                  <a:uFillTx/>
+                                  <a:latin typeface="Cambria Math" panose="02040503050406030204" pitchFamily="18" charset="0"/>
+                                </a:rPr>
+                              </m:ctrlPr>
+                            </m:sSupPr>
+                            <m:e>
+                              <m:r>
+                                <a:rPr lang="en-US" sz="2300" b="0" i="1" u="none" strike="noStrike" smtClean="0">
+                                  <a:solidFill>
+                                    <a:srgbClr val="000000"/>
+                                  </a:solidFill>
+                                  <a:effectLst/>
+                                  <a:uFillTx/>
+                                  <a:latin typeface="Cambria Math" panose="02040503050406030204" pitchFamily="18" charset="0"/>
+                                </a:rPr>
+                                <m:t>𝑧</m:t>
+                              </m:r>
+                            </m:e>
+                            <m:sup>
+                              <m:r>
+                                <a:rPr lang="en-US" sz="2300" b="0" i="1" u="none" strike="noStrike" smtClean="0">
+                                  <a:solidFill>
+                                    <a:srgbClr val="000000"/>
+                                  </a:solidFill>
+                                  <a:effectLst/>
+                                  <a:uFillTx/>
+                                  <a:latin typeface="Cambria Math" panose="02040503050406030204" pitchFamily="18" charset="0"/>
+                                </a:rPr>
+                                <m:t>−1</m:t>
+                              </m:r>
+                            </m:sup>
+                          </m:sSup>
+                        </m:num>
+                        <m:den>
+                          <m:r>
+                            <a:rPr lang="en-US" sz="2300" b="0" i="1" u="none" strike="noStrike" smtClean="0">
+                              <a:solidFill>
+                                <a:srgbClr val="000000"/>
+                              </a:solidFill>
+                              <a:effectLst/>
+                              <a:uFillTx/>
+                              <a:latin typeface="Cambria Math" panose="02040503050406030204" pitchFamily="18" charset="0"/>
+                            </a:rPr>
+                            <m:t>1−0.5</m:t>
+                          </m:r>
+                          <m:sSup>
+                            <m:sSupPr>
+                              <m:ctrlPr>
+                                <a:rPr lang="en-US" sz="2300" b="0" i="1" u="none" strike="noStrike" smtClean="0">
+                                  <a:solidFill>
+                                    <a:srgbClr val="000000"/>
+                                  </a:solidFill>
+                                  <a:effectLst/>
+                                  <a:uFillTx/>
+                                  <a:latin typeface="Cambria Math" panose="02040503050406030204" pitchFamily="18" charset="0"/>
+                                </a:rPr>
+                              </m:ctrlPr>
+                            </m:sSupPr>
+                            <m:e>
+                              <m:r>
+                                <a:rPr lang="en-US" sz="2300" b="0" i="1" u="none" strike="noStrike" smtClean="0">
+                                  <a:solidFill>
+                                    <a:srgbClr val="000000"/>
+                                  </a:solidFill>
+                                  <a:effectLst/>
+                                  <a:uFillTx/>
+                                  <a:latin typeface="Cambria Math" panose="02040503050406030204" pitchFamily="18" charset="0"/>
+                                </a:rPr>
+                                <m:t>𝑧</m:t>
+                              </m:r>
+                            </m:e>
+                            <m:sup>
+                              <m:r>
+                                <a:rPr lang="en-US" sz="2300" b="0" i="1" u="none" strike="noStrike" smtClean="0">
+                                  <a:solidFill>
+                                    <a:srgbClr val="000000"/>
+                                  </a:solidFill>
+                                  <a:effectLst/>
+                                  <a:uFillTx/>
+                                  <a:latin typeface="Cambria Math" panose="02040503050406030204" pitchFamily="18" charset="0"/>
+                                </a:rPr>
+                                <m:t>−1</m:t>
+                              </m:r>
+                            </m:sup>
+                          </m:sSup>
+                        </m:den>
+                      </m:f>
+                    </m:oMath>
+                  </m:oMathPara>
+                </a14:m>
+                <a:endParaRPr lang="en-US" sz="2300" b="0" u="none" strike="noStrike" dirty="0">
+                  <a:solidFill>
+                    <a:srgbClr val="000000"/>
+                  </a:solidFill>
+                  <a:effectLst/>
+                  <a:uFillTx/>
+                  <a:latin typeface="Arial"/>
+                </a:endParaRPr>
+              </a:p>
+            </p:txBody>
+          </p:sp>
+        </mc:Choice>
+        <mc:Fallback>
+          <p:sp>
+            <p:nvSpPr>
+              <p:cNvPr id="49" name="Text 5"/>
+              <p:cNvSpPr>
+                <a:spLocks noRot="1" noChangeAspect="1" noMove="1" noResize="1" noEditPoints="1" noAdjustHandles="1" noChangeArrowheads="1" noChangeShapeType="1" noTextEdit="1"/>
+              </p:cNvSpPr>
+              <p:nvPr/>
+            </p:nvSpPr>
+            <p:spPr>
+              <a:xfrm>
+                <a:off x="731520" y="1234800"/>
+                <a:ext cx="5303160" cy="948030"/>
+              </a:xfrm>
+              <a:prstGeom prst="rect">
+                <a:avLst/>
+              </a:prstGeom>
+              <a:blipFill>
+                <a:blip r:embed="rId3"/>
+                <a:stretch>
+                  <a:fillRect/>
+                </a:stretch>
+              </a:blipFill>
+              <a:ln w="12700">
+                <a:solidFill>
+                  <a:srgbClr val="D7E0EA"/>
+                </a:solidFill>
+                <a:round/>
+              </a:ln>
+            </p:spPr>
+            <p:txBody>
+              <a:bodyPr/>
+              <a:lstStyle/>
+              <a:p>
+                <a:r>
+                  <a:rPr lang="en-US">
+                    <a:noFill/>
+                  </a:rPr>
+                  <a:t> </a:t>
+                </a:r>
+              </a:p>
+            </p:txBody>
+          </p:sp>
+        </mc:Fallback>
+      </mc:AlternateContent>
       <p:sp>
         <p:nvSpPr>
           <p:cNvPr id="50" name="Shape 6"/>
@@ -16736,73 +18441,214 @@
           </a:p>
         </p:txBody>
       </p:sp>
-      <p:sp>
-        <p:nvSpPr>
-          <p:cNvPr id="52" name="Text 8"/>
-          <p:cNvSpPr/>
-          <p:nvPr/>
-        </p:nvSpPr>
-        <p:spPr>
-          <a:xfrm>
-            <a:off x="877680" y="2816280"/>
-            <a:ext cx="5010480" cy="1115280"/>
-          </a:xfrm>
-          <a:prstGeom prst="rect">
-            <a:avLst/>
-          </a:prstGeom>
-          <a:noFill/>
-          <a:ln w="0">
-            <a:noFill/>
-          </a:ln>
-        </p:spPr>
-        <p:style>
-          <a:lnRef idx="0">
-            <a:scrgbClr r="0" g="0" b="0"/>
-          </a:lnRef>
-          <a:fillRef idx="0">
-            <a:scrgbClr r="0" g="0" b="0"/>
-          </a:fillRef>
-          <a:effectRef idx="0">
-            <a:scrgbClr r="0" g="0" b="0"/>
-          </a:effectRef>
-          <a:fontRef idx="minor"/>
-        </p:style>
-        <p:txBody>
-          <a:bodyPr lIns="360" tIns="360" rIns="360" bIns="360" anchor="t">
-            <a:noAutofit/>
-          </a:bodyPr>
-          <a:lstStyle/>
-          <a:p>
-            <a:pPr defTabSz="914400">
-              <a:lnSpc>
-                <a:spcPct val="100000"/>
-              </a:lnSpc>
-              <a:tabLst>
-                <a:tab pos="0" algn="l"/>
-              </a:tabLst>
-            </a:pPr>
-            <a:r>
-              <a:rPr lang="en-US" sz="1600" b="0" u="none" strike="noStrike">
-                <a:solidFill>
-                  <a:srgbClr val="1F2937"/>
-                </a:solidFill>
-                <a:effectLst/>
-                <a:uFillTx/>
-                <a:latin typeface="Aptos"/>
-              </a:rPr>
-              <a:t>The unit-circle point is $z=1$. The zero-distance is $0.2$ and pole-distance is $0.5$, so $|H(1)|=0.4$.</a:t>
-            </a:r>
-            <a:endParaRPr lang="en-US" sz="1600" b="0" u="none" strike="noStrike">
-              <a:solidFill>
-                <a:srgbClr val="000000"/>
-              </a:solidFill>
-              <a:effectLst/>
-              <a:uFillTx/>
-              <a:latin typeface="Arial"/>
-            </a:endParaRPr>
-          </a:p>
-        </p:txBody>
-      </p:sp>
+      <mc:AlternateContent xmlns:mc="http://schemas.openxmlformats.org/markup-compatibility/2006">
+        <mc:Choice xmlns:a14="http://schemas.microsoft.com/office/drawing/2010/main" Requires="a14">
+          <p:sp>
+            <p:nvSpPr>
+              <p:cNvPr id="52" name="Text 8"/>
+              <p:cNvSpPr/>
+              <p:nvPr/>
+            </p:nvSpPr>
+            <p:spPr>
+              <a:xfrm>
+                <a:off x="877680" y="2816280"/>
+                <a:ext cx="5010480" cy="1115280"/>
+              </a:xfrm>
+              <a:prstGeom prst="rect">
+                <a:avLst/>
+              </a:prstGeom>
+              <a:noFill/>
+              <a:ln w="0">
+                <a:noFill/>
+              </a:ln>
+            </p:spPr>
+            <p:style>
+              <a:lnRef idx="0">
+                <a:scrgbClr r="0" g="0" b="0"/>
+              </a:lnRef>
+              <a:fillRef idx="0">
+                <a:scrgbClr r="0" g="0" b="0"/>
+              </a:fillRef>
+              <a:effectRef idx="0">
+                <a:scrgbClr r="0" g="0" b="0"/>
+              </a:effectRef>
+              <a:fontRef idx="minor"/>
+            </p:style>
+            <p:txBody>
+              <a:bodyPr lIns="360" tIns="360" rIns="360" bIns="360" anchor="t">
+                <a:noAutofit/>
+              </a:bodyPr>
+              <a:lstStyle/>
+              <a:p>
+                <a:pPr defTabSz="914400">
+                  <a:lnSpc>
+                    <a:spcPct val="100000"/>
+                  </a:lnSpc>
+                  <a:tabLst>
+                    <a:tab pos="0" algn="l"/>
+                  </a:tabLst>
+                </a:pPr>
+                <a:r>
+                  <a:rPr lang="en-US" sz="1600" b="0" u="none" strike="noStrike" dirty="0">
+                    <a:solidFill>
+                      <a:srgbClr val="1F2937"/>
+                    </a:solidFill>
+                    <a:effectLst/>
+                    <a:uFillTx/>
+                    <a:latin typeface="Aptos"/>
+                  </a:rPr>
+                  <a:t>The unit-circle point is </a:t>
+                </a:r>
+                <a14:m>
+                  <m:oMath xmlns:m="http://schemas.openxmlformats.org/officeDocument/2006/math">
+                    <m:r>
+                      <a:rPr lang="en-US" sz="1600" b="0" i="1" u="none" strike="noStrike" dirty="0" smtClean="0">
+                        <a:solidFill>
+                          <a:srgbClr val="1F2937"/>
+                        </a:solidFill>
+                        <a:effectLst/>
+                        <a:uFillTx/>
+                        <a:latin typeface="Cambria Math" panose="02040503050406030204" pitchFamily="18" charset="0"/>
+                      </a:rPr>
+                      <m:t>𝑧</m:t>
+                    </m:r>
+                    <m:r>
+                      <a:rPr lang="en-US" sz="1600" b="0" i="1" u="none" strike="noStrike" dirty="0">
+                        <a:solidFill>
+                          <a:srgbClr val="1F2937"/>
+                        </a:solidFill>
+                        <a:effectLst/>
+                        <a:uFillTx/>
+                        <a:latin typeface="Cambria Math" panose="02040503050406030204" pitchFamily="18" charset="0"/>
+                      </a:rPr>
+                      <m:t>=</m:t>
+                    </m:r>
+                    <m:r>
+                      <a:rPr lang="en-US" sz="1600" b="0" i="1" u="none" strike="noStrike" dirty="0" smtClean="0">
+                        <a:solidFill>
+                          <a:srgbClr val="1F2937"/>
+                        </a:solidFill>
+                        <a:effectLst/>
+                        <a:uFillTx/>
+                        <a:latin typeface="Cambria Math" panose="02040503050406030204" pitchFamily="18" charset="0"/>
+                      </a:rPr>
+                      <m:t>1</m:t>
+                    </m:r>
+                  </m:oMath>
+                </a14:m>
+                <a:r>
+                  <a:rPr lang="en-US" sz="1600" b="0" u="none" strike="noStrike" dirty="0">
+                    <a:solidFill>
+                      <a:srgbClr val="1F2937"/>
+                    </a:solidFill>
+                    <a:effectLst/>
+                    <a:uFillTx/>
+                    <a:latin typeface="Aptos"/>
+                  </a:rPr>
+                  <a:t>. The zero-distance is 0.2 and pole-distance is 0.5, so </a:t>
+                </a:r>
+                <a14:m>
+                  <m:oMath xmlns:m="http://schemas.openxmlformats.org/officeDocument/2006/math">
+                    <m:r>
+                      <a:rPr lang="en-US" sz="1600" b="0" i="1" u="none" strike="noStrike" dirty="0" smtClean="0">
+                        <a:solidFill>
+                          <a:srgbClr val="1F2937"/>
+                        </a:solidFill>
+                        <a:effectLst/>
+                        <a:uFillTx/>
+                        <a:latin typeface="Cambria Math" panose="02040503050406030204" pitchFamily="18" charset="0"/>
+                      </a:rPr>
+                      <m:t>|</m:t>
+                    </m:r>
+                    <m:r>
+                      <a:rPr lang="en-US" sz="1600" b="0" i="1" u="none" strike="noStrike" dirty="0">
+                        <a:solidFill>
+                          <a:srgbClr val="1F2937"/>
+                        </a:solidFill>
+                        <a:effectLst/>
+                        <a:uFillTx/>
+                        <a:latin typeface="Cambria Math" panose="02040503050406030204" pitchFamily="18" charset="0"/>
+                      </a:rPr>
+                      <m:t>𝐻</m:t>
+                    </m:r>
+                    <m:r>
+                      <a:rPr lang="en-US" sz="1600" b="0" i="1" u="none" strike="noStrike" dirty="0">
+                        <a:solidFill>
+                          <a:srgbClr val="1F2937"/>
+                        </a:solidFill>
+                        <a:effectLst/>
+                        <a:uFillTx/>
+                        <a:latin typeface="Cambria Math" panose="02040503050406030204" pitchFamily="18" charset="0"/>
+                      </a:rPr>
+                      <m:t>(1)|=0.4</m:t>
+                    </m:r>
+                  </m:oMath>
+                </a14:m>
+                <a:r>
+                  <a:rPr lang="en-US" sz="1600" b="0" u="none" strike="noStrike" dirty="0">
+                    <a:solidFill>
+                      <a:srgbClr val="1F2937"/>
+                    </a:solidFill>
+                    <a:effectLst/>
+                    <a:uFillTx/>
+                    <a:latin typeface="Aptos"/>
+                  </a:rPr>
+                  <a:t>.</a:t>
+                </a:r>
+                <a:endParaRPr lang="en-US" sz="1600" b="0" u="none" strike="noStrike" dirty="0">
+                  <a:solidFill>
+                    <a:srgbClr val="000000"/>
+                  </a:solidFill>
+                  <a:effectLst/>
+                  <a:uFillTx/>
+                  <a:latin typeface="Arial"/>
+                </a:endParaRPr>
+              </a:p>
+            </p:txBody>
+          </p:sp>
+        </mc:Choice>
+        <mc:Fallback>
+          <p:sp>
+            <p:nvSpPr>
+              <p:cNvPr id="52" name="Text 8"/>
+              <p:cNvSpPr>
+                <a:spLocks noRot="1" noChangeAspect="1" noMove="1" noResize="1" noEditPoints="1" noAdjustHandles="1" noChangeArrowheads="1" noChangeShapeType="1" noTextEdit="1"/>
+              </p:cNvSpPr>
+              <p:nvPr/>
+            </p:nvSpPr>
+            <p:spPr>
+              <a:xfrm>
+                <a:off x="877680" y="2816280"/>
+                <a:ext cx="5010480" cy="1115280"/>
+              </a:xfrm>
+              <a:prstGeom prst="rect">
+                <a:avLst/>
+              </a:prstGeom>
+              <a:blipFill>
+                <a:blip r:embed="rId4"/>
+                <a:stretch>
+                  <a:fillRect l="-2433" t="-5464" r="-3041"/>
+                </a:stretch>
+              </a:blipFill>
+              <a:ln w="0">
+                <a:noFill/>
+              </a:ln>
+            </p:spPr>
+            <p:txBody>
+              <a:bodyPr/>
+              <a:lstStyle/>
+              <a:p>
+                <a:r>
+                  <a:rPr lang="en-US">
+                    <a:noFill/>
+                  </a:rPr>
+                  <a:t> </a:t>
+                </a:r>
+              </a:p>
+            </p:txBody>
+          </p:sp>
+        </mc:Fallback>
+      </mc:AlternateContent>
       <p:sp>
         <p:nvSpPr>
           <p:cNvPr id="53" name="Shape 9"/>
@@ -16925,73 +18771,214 @@
           </a:p>
         </p:txBody>
       </p:sp>
-      <p:sp>
-        <p:nvSpPr>
-          <p:cNvPr id="55" name="Text 11"/>
-          <p:cNvSpPr/>
-          <p:nvPr/>
-        </p:nvSpPr>
-        <p:spPr>
-          <a:xfrm>
-            <a:off x="877680" y="4736520"/>
-            <a:ext cx="5010480" cy="1115280"/>
-          </a:xfrm>
-          <a:prstGeom prst="rect">
-            <a:avLst/>
-          </a:prstGeom>
-          <a:noFill/>
-          <a:ln w="0">
-            <a:noFill/>
-          </a:ln>
-        </p:spPr>
-        <p:style>
-          <a:lnRef idx="0">
-            <a:scrgbClr r="0" g="0" b="0"/>
-          </a:lnRef>
-          <a:fillRef idx="0">
-            <a:scrgbClr r="0" g="0" b="0"/>
-          </a:fillRef>
-          <a:effectRef idx="0">
-            <a:scrgbClr r="0" g="0" b="0"/>
-          </a:effectRef>
-          <a:fontRef idx="minor"/>
-        </p:style>
-        <p:txBody>
-          <a:bodyPr lIns="360" tIns="360" rIns="360" bIns="360" anchor="t">
-            <a:noAutofit/>
-          </a:bodyPr>
-          <a:lstStyle/>
-          <a:p>
-            <a:pPr defTabSz="914400">
-              <a:lnSpc>
-                <a:spcPct val="100000"/>
-              </a:lnSpc>
-              <a:tabLst>
-                <a:tab pos="0" algn="l"/>
-              </a:tabLst>
-            </a:pPr>
-            <a:r>
-              <a:rPr lang="en-US" sz="1600" b="0" u="none" strike="noStrike">
-                <a:solidFill>
-                  <a:srgbClr val="1F2937"/>
-                </a:solidFill>
-                <a:effectLst/>
-                <a:uFillTx/>
-                <a:latin typeface="Aptos"/>
-              </a:rPr>
-              <a:t>The point is $z=-1$. The distances are $1.8$ and $1.5$, so $|H(-1)|=1.2$. Predict a high-frequency tilt before plotting.</a:t>
-            </a:r>
-            <a:endParaRPr lang="en-US" sz="1600" b="0" u="none" strike="noStrike">
-              <a:solidFill>
-                <a:srgbClr val="000000"/>
-              </a:solidFill>
-              <a:effectLst/>
-              <a:uFillTx/>
-              <a:latin typeface="Arial"/>
-            </a:endParaRPr>
-          </a:p>
-        </p:txBody>
-      </p:sp>
+      <mc:AlternateContent xmlns:mc="http://schemas.openxmlformats.org/markup-compatibility/2006">
+        <mc:Choice xmlns:a14="http://schemas.microsoft.com/office/drawing/2010/main" Requires="a14">
+          <p:sp>
+            <p:nvSpPr>
+              <p:cNvPr id="55" name="Text 11"/>
+              <p:cNvSpPr/>
+              <p:nvPr/>
+            </p:nvSpPr>
+            <p:spPr>
+              <a:xfrm>
+                <a:off x="877680" y="4736520"/>
+                <a:ext cx="5010480" cy="1115280"/>
+              </a:xfrm>
+              <a:prstGeom prst="rect">
+                <a:avLst/>
+              </a:prstGeom>
+              <a:noFill/>
+              <a:ln w="0">
+                <a:noFill/>
+              </a:ln>
+            </p:spPr>
+            <p:style>
+              <a:lnRef idx="0">
+                <a:scrgbClr r="0" g="0" b="0"/>
+              </a:lnRef>
+              <a:fillRef idx="0">
+                <a:scrgbClr r="0" g="0" b="0"/>
+              </a:fillRef>
+              <a:effectRef idx="0">
+                <a:scrgbClr r="0" g="0" b="0"/>
+              </a:effectRef>
+              <a:fontRef idx="minor"/>
+            </p:style>
+            <p:txBody>
+              <a:bodyPr lIns="360" tIns="360" rIns="360" bIns="360" anchor="t">
+                <a:noAutofit/>
+              </a:bodyPr>
+              <a:lstStyle/>
+              <a:p>
+                <a:pPr defTabSz="914400">
+                  <a:lnSpc>
+                    <a:spcPct val="100000"/>
+                  </a:lnSpc>
+                  <a:tabLst>
+                    <a:tab pos="0" algn="l"/>
+                  </a:tabLst>
+                </a:pPr>
+                <a:r>
+                  <a:rPr lang="en-US" sz="1600" b="0" u="none" strike="noStrike" dirty="0">
+                    <a:solidFill>
+                      <a:srgbClr val="1F2937"/>
+                    </a:solidFill>
+                    <a:effectLst/>
+                    <a:uFillTx/>
+                    <a:latin typeface="Aptos"/>
+                  </a:rPr>
+                  <a:t>The point is </a:t>
+                </a:r>
+                <a14:m>
+                  <m:oMath xmlns:m="http://schemas.openxmlformats.org/officeDocument/2006/math">
+                    <m:r>
+                      <a:rPr lang="en-US" sz="1600" b="0" i="1" u="none" strike="noStrike" dirty="0" smtClean="0">
+                        <a:solidFill>
+                          <a:srgbClr val="1F2937"/>
+                        </a:solidFill>
+                        <a:effectLst/>
+                        <a:uFillTx/>
+                        <a:latin typeface="Cambria Math" panose="02040503050406030204" pitchFamily="18" charset="0"/>
+                      </a:rPr>
+                      <m:t>𝑧</m:t>
+                    </m:r>
+                    <m:r>
+                      <a:rPr lang="en-US" sz="1600" b="0" i="1" u="none" strike="noStrike" dirty="0">
+                        <a:solidFill>
+                          <a:srgbClr val="1F2937"/>
+                        </a:solidFill>
+                        <a:effectLst/>
+                        <a:uFillTx/>
+                        <a:latin typeface="Cambria Math" panose="02040503050406030204" pitchFamily="18" charset="0"/>
+                      </a:rPr>
+                      <m:t>=−</m:t>
+                    </m:r>
+                    <m:r>
+                      <a:rPr lang="en-US" sz="1600" b="0" i="1" u="none" strike="noStrike" dirty="0" smtClean="0">
+                        <a:solidFill>
+                          <a:srgbClr val="1F2937"/>
+                        </a:solidFill>
+                        <a:effectLst/>
+                        <a:uFillTx/>
+                        <a:latin typeface="Cambria Math" panose="02040503050406030204" pitchFamily="18" charset="0"/>
+                      </a:rPr>
+                      <m:t>1</m:t>
+                    </m:r>
+                  </m:oMath>
+                </a14:m>
+                <a:r>
+                  <a:rPr lang="en-US" sz="1600" b="0" u="none" strike="noStrike" dirty="0">
+                    <a:solidFill>
+                      <a:srgbClr val="1F2937"/>
+                    </a:solidFill>
+                    <a:effectLst/>
+                    <a:uFillTx/>
+                    <a:latin typeface="Aptos"/>
+                  </a:rPr>
+                  <a:t>. The distances are 1.8 and 1.5, so </a:t>
+                </a:r>
+                <a14:m>
+                  <m:oMath xmlns:m="http://schemas.openxmlformats.org/officeDocument/2006/math">
+                    <m:r>
+                      <a:rPr lang="en-US" sz="1600" b="0" i="1" u="none" strike="noStrike" dirty="0" smtClean="0">
+                        <a:solidFill>
+                          <a:srgbClr val="1F2937"/>
+                        </a:solidFill>
+                        <a:effectLst/>
+                        <a:uFillTx/>
+                        <a:latin typeface="Cambria Math" panose="02040503050406030204" pitchFamily="18" charset="0"/>
+                      </a:rPr>
+                      <m:t>|</m:t>
+                    </m:r>
+                    <m:r>
+                      <a:rPr lang="en-US" sz="1600" b="0" i="1" u="none" strike="noStrike" dirty="0">
+                        <a:solidFill>
+                          <a:srgbClr val="1F2937"/>
+                        </a:solidFill>
+                        <a:effectLst/>
+                        <a:uFillTx/>
+                        <a:latin typeface="Cambria Math" panose="02040503050406030204" pitchFamily="18" charset="0"/>
+                      </a:rPr>
+                      <m:t>𝐻</m:t>
+                    </m:r>
+                    <m:r>
+                      <a:rPr lang="en-US" sz="1600" b="0" i="1" u="none" strike="noStrike" dirty="0">
+                        <a:solidFill>
+                          <a:srgbClr val="1F2937"/>
+                        </a:solidFill>
+                        <a:effectLst/>
+                        <a:uFillTx/>
+                        <a:latin typeface="Cambria Math" panose="02040503050406030204" pitchFamily="18" charset="0"/>
+                      </a:rPr>
+                      <m:t>(−1)|=1.2</m:t>
+                    </m:r>
+                  </m:oMath>
+                </a14:m>
+                <a:r>
+                  <a:rPr lang="en-US" sz="1600" b="0" u="none" strike="noStrike" dirty="0">
+                    <a:solidFill>
+                      <a:srgbClr val="1F2937"/>
+                    </a:solidFill>
+                    <a:effectLst/>
+                    <a:uFillTx/>
+                    <a:latin typeface="Aptos"/>
+                  </a:rPr>
+                  <a:t>. Predict a high-frequency tilt before plotting.</a:t>
+                </a:r>
+                <a:endParaRPr lang="en-US" sz="1600" b="0" u="none" strike="noStrike" dirty="0">
+                  <a:solidFill>
+                    <a:srgbClr val="000000"/>
+                  </a:solidFill>
+                  <a:effectLst/>
+                  <a:uFillTx/>
+                  <a:latin typeface="Arial"/>
+                </a:endParaRPr>
+              </a:p>
+            </p:txBody>
+          </p:sp>
+        </mc:Choice>
+        <mc:Fallback>
+          <p:sp>
+            <p:nvSpPr>
+              <p:cNvPr id="55" name="Text 11"/>
+              <p:cNvSpPr>
+                <a:spLocks noRot="1" noChangeAspect="1" noMove="1" noResize="1" noEditPoints="1" noAdjustHandles="1" noChangeArrowheads="1" noChangeShapeType="1" noTextEdit="1"/>
+              </p:cNvSpPr>
+              <p:nvPr/>
+            </p:nvSpPr>
+            <p:spPr>
+              <a:xfrm>
+                <a:off x="877680" y="4736520"/>
+                <a:ext cx="5010480" cy="1115280"/>
+              </a:xfrm>
+              <a:prstGeom prst="rect">
+                <a:avLst/>
+              </a:prstGeom>
+              <a:blipFill>
+                <a:blip r:embed="rId5"/>
+                <a:stretch>
+                  <a:fillRect l="-2433" t="-5464"/>
+                </a:stretch>
+              </a:blipFill>
+              <a:ln w="0">
+                <a:noFill/>
+              </a:ln>
+            </p:spPr>
+            <p:txBody>
+              <a:bodyPr/>
+              <a:lstStyle/>
+              <a:p>
+                <a:r>
+                  <a:rPr lang="en-US">
+                    <a:noFill/>
+                  </a:rPr>
+                  <a:t> </a:t>
+                </a:r>
+              </a:p>
+            </p:txBody>
+          </p:sp>
+        </mc:Fallback>
+      </mc:AlternateContent>
       <p:pic>
         <p:nvPicPr>
           <p:cNvPr id="56" name="Image 0" descr="/mnt/data/week5_lectures9_10/assets/L9_mag.png"/>
@@ -16999,7 +18986,7 @@
           <p:nvPr/>
         </p:nvPicPr>
         <p:blipFill>
-          <a:blip r:embed="rId3"/>
+          <a:blip r:embed="rId6"/>
           <a:stretch/>
         </p:blipFill>
         <p:spPr>
@@ -17367,137 +19354,298 @@
           </a:p>
         </p:txBody>
       </p:sp>
-      <p:sp>
-        <p:nvSpPr>
-          <p:cNvPr id="62" name="Text 5"/>
-          <p:cNvSpPr/>
-          <p:nvPr/>
-        </p:nvSpPr>
-        <p:spPr>
-          <a:xfrm>
-            <a:off x="777240" y="1417320"/>
-            <a:ext cx="10515240" cy="3931560"/>
-          </a:xfrm>
-          <a:prstGeom prst="rect">
-            <a:avLst/>
-          </a:prstGeom>
-          <a:noFill/>
-          <a:ln w="0">
-            <a:noFill/>
-          </a:ln>
-        </p:spPr>
-        <p:style>
-          <a:lnRef idx="0">
-            <a:scrgbClr r="0" g="0" b="0"/>
-          </a:lnRef>
-          <a:fillRef idx="0">
-            <a:scrgbClr r="0" g="0" b="0"/>
-          </a:fillRef>
-          <a:effectRef idx="0">
-            <a:scrgbClr r="0" g="0" b="0"/>
-          </a:effectRef>
-          <a:fontRef idx="minor"/>
-        </p:style>
-        <p:txBody>
-          <a:bodyPr lIns="720" tIns="720" rIns="720" bIns="720" anchor="t">
-            <a:noAutofit/>
-          </a:bodyPr>
-          <a:lstStyle/>
-          <a:p>
-            <a:pPr marL="228600" indent="-228600" defTabSz="914400">
-              <a:lnSpc>
-                <a:spcPct val="100000"/>
-              </a:lnSpc>
-              <a:buClr>
-                <a:srgbClr val="1F2937"/>
-              </a:buClr>
-              <a:buFont typeface="Symbol" charset="2"/>
-              <a:buChar char=""/>
-            </a:pPr>
-            <a:r>
-              <a:rPr lang="en-US" sz="1800" b="0" u="none" strike="noStrike">
-                <a:solidFill>
-                  <a:srgbClr val="1F2937"/>
-                </a:solidFill>
-                <a:effectLst/>
-                <a:uFillTx/>
-                <a:latin typeface="Aptos"/>
-              </a:rPr>
-              <a:t>A pole at angle $\omega_0$ moves radially from radius $0.5$ to radius $0.95$. What happens near $\omega_0$?</a:t>
-            </a:r>
-            <a:endParaRPr lang="en-US" sz="1800" b="0" u="none" strike="noStrike">
-              <a:solidFill>
-                <a:srgbClr val="000000"/>
-              </a:solidFill>
-              <a:effectLst/>
-              <a:uFillTx/>
-              <a:latin typeface="Arial"/>
-            </a:endParaRPr>
-          </a:p>
-          <a:p>
-            <a:pPr marL="228600" indent="-228600" defTabSz="914400">
-              <a:lnSpc>
-                <a:spcPct val="100000"/>
-              </a:lnSpc>
-              <a:buClr>
-                <a:srgbClr val="1F2937"/>
-              </a:buClr>
-              <a:buFont typeface="Symbol" charset="2"/>
-              <a:buChar char=""/>
-            </a:pPr>
-            <a:r>
-              <a:rPr lang="en-US" sz="1800" b="0" u="none" strike="noStrike">
-                <a:solidFill>
-                  <a:srgbClr val="1F2937"/>
-                </a:solidFill>
-                <a:effectLst/>
-                <a:uFillTx/>
-                <a:latin typeface="Aptos"/>
-              </a:rPr>
-              <a:t>Good answer: the denominator vector becomes much shorter, so magnitude increases sharply and the phase changes more rapidly.</a:t>
-            </a:r>
-            <a:endParaRPr lang="en-US" sz="1800" b="0" u="none" strike="noStrike">
-              <a:solidFill>
-                <a:srgbClr val="000000"/>
-              </a:solidFill>
-              <a:effectLst/>
-              <a:uFillTx/>
-              <a:latin typeface="Arial"/>
-            </a:endParaRPr>
-          </a:p>
-          <a:p>
-            <a:pPr marL="228600" indent="-228600" defTabSz="914400">
-              <a:lnSpc>
-                <a:spcPct val="100000"/>
-              </a:lnSpc>
-              <a:buClr>
-                <a:srgbClr val="1F2937"/>
-              </a:buClr>
-              <a:buFont typeface="Symbol" charset="2"/>
-              <a:buChar char=""/>
-            </a:pPr>
-            <a:r>
-              <a:rPr lang="en-US" sz="1800" b="0" u="none" strike="noStrike">
-                <a:solidFill>
-                  <a:srgbClr val="1F2937"/>
-                </a:solidFill>
-                <a:effectLst/>
-                <a:uFillTx/>
-                <a:latin typeface="Aptos"/>
-              </a:rPr>
-              <a:t>Graduate-level addition: the pole also produces a more concentrated group-delay contribution near its angle.</a:t>
-            </a:r>
-            <a:endParaRPr lang="en-US" sz="1800" b="0" u="none" strike="noStrike">
-              <a:solidFill>
-                <a:srgbClr val="000000"/>
-              </a:solidFill>
-              <a:effectLst/>
-              <a:uFillTx/>
-              <a:latin typeface="Arial"/>
-            </a:endParaRPr>
-          </a:p>
-        </p:txBody>
-      </p:sp>
+      <mc:AlternateContent xmlns:mc="http://schemas.openxmlformats.org/markup-compatibility/2006">
+        <mc:Choice xmlns:a14="http://schemas.microsoft.com/office/drawing/2010/main" Requires="a14">
+          <p:sp>
+            <p:nvSpPr>
+              <p:cNvPr id="62" name="Text 5"/>
+              <p:cNvSpPr/>
+              <p:nvPr/>
+            </p:nvSpPr>
+            <p:spPr>
+              <a:xfrm>
+                <a:off x="777240" y="1417320"/>
+                <a:ext cx="10515240" cy="3931560"/>
+              </a:xfrm>
+              <a:prstGeom prst="rect">
+                <a:avLst/>
+              </a:prstGeom>
+              <a:noFill/>
+              <a:ln w="0">
+                <a:noFill/>
+              </a:ln>
+            </p:spPr>
+            <p:style>
+              <a:lnRef idx="0">
+                <a:scrgbClr r="0" g="0" b="0"/>
+              </a:lnRef>
+              <a:fillRef idx="0">
+                <a:scrgbClr r="0" g="0" b="0"/>
+              </a:fillRef>
+              <a:effectRef idx="0">
+                <a:scrgbClr r="0" g="0" b="0"/>
+              </a:effectRef>
+              <a:fontRef idx="minor"/>
+            </p:style>
+            <p:txBody>
+              <a:bodyPr lIns="720" tIns="720" rIns="720" bIns="720" anchor="t">
+                <a:noAutofit/>
+              </a:bodyPr>
+              <a:lstStyle/>
+              <a:p>
+                <a:pPr marL="228600" indent="-228600" defTabSz="914400">
+                  <a:lnSpc>
+                    <a:spcPct val="100000"/>
+                  </a:lnSpc>
+                  <a:buClr>
+                    <a:srgbClr val="1F2937"/>
+                  </a:buClr>
+                  <a:buFont typeface="Symbol" charset="2"/>
+                  <a:buChar char=""/>
+                </a:pPr>
+                <a:r>
+                  <a:rPr lang="en-US" sz="1800" b="0" u="none" strike="noStrike" dirty="0">
+                    <a:solidFill>
+                      <a:srgbClr val="1F2937"/>
+                    </a:solidFill>
+                    <a:effectLst/>
+                    <a:uFillTx/>
+                    <a:latin typeface="Aptos"/>
+                  </a:rPr>
+                  <a:t>A pole at angle </a:t>
+                </a:r>
+                <a14:m>
+                  <m:oMath xmlns:m="http://schemas.openxmlformats.org/officeDocument/2006/math">
+                    <m:sSub>
+                      <m:sSubPr>
+                        <m:ctrlPr>
+                          <a:rPr lang="en-US" sz="1800" b="0" i="1" u="none" strike="noStrike" smtClean="0">
+                            <a:solidFill>
+                              <a:srgbClr val="1F2937"/>
+                            </a:solidFill>
+                            <a:effectLst/>
+                            <a:uFillTx/>
+                            <a:latin typeface="Cambria Math" panose="02040503050406030204" pitchFamily="18" charset="0"/>
+                            <a:ea typeface="Cambria Math" panose="02040503050406030204" pitchFamily="18" charset="0"/>
+                          </a:rPr>
+                        </m:ctrlPr>
+                      </m:sSubPr>
+                      <m:e>
+                        <m:r>
+                          <a:rPr lang="en-US" sz="1800" b="0" i="1" u="none" strike="noStrike" smtClean="0">
+                            <a:solidFill>
+                              <a:srgbClr val="1F2937"/>
+                            </a:solidFill>
+                            <a:effectLst/>
+                            <a:uFillTx/>
+                            <a:latin typeface="Cambria Math" panose="02040503050406030204" pitchFamily="18" charset="0"/>
+                            <a:ea typeface="Cambria Math" panose="02040503050406030204" pitchFamily="18" charset="0"/>
+                          </a:rPr>
+                          <m:t>𝜔</m:t>
+                        </m:r>
+                      </m:e>
+                      <m:sub>
+                        <m:r>
+                          <a:rPr lang="en-US" sz="1800" b="0" i="1" u="none" strike="noStrike" smtClean="0">
+                            <a:solidFill>
+                              <a:srgbClr val="1F2937"/>
+                            </a:solidFill>
+                            <a:effectLst/>
+                            <a:uFillTx/>
+                            <a:latin typeface="Cambria Math" panose="02040503050406030204" pitchFamily="18" charset="0"/>
+                            <a:ea typeface="Cambria Math" panose="02040503050406030204" pitchFamily="18" charset="0"/>
+                          </a:rPr>
+                          <m:t>0</m:t>
+                        </m:r>
+                      </m:sub>
+                    </m:sSub>
+                  </m:oMath>
+                </a14:m>
+                <a:r>
+                  <a:rPr lang="en-US" sz="1800" b="0" u="none" strike="noStrike" dirty="0">
+                    <a:solidFill>
+                      <a:srgbClr val="1F2937"/>
+                    </a:solidFill>
+                    <a:effectLst/>
+                    <a:uFillTx/>
+                    <a:latin typeface="Aptos"/>
+                  </a:rPr>
+                  <a:t> moves radially from radius 0.5 to radius 0.95. What happens near </a:t>
+                </a:r>
+                <a14:m>
+                  <m:oMath xmlns:m="http://schemas.openxmlformats.org/officeDocument/2006/math">
+                    <m:sSub>
+                      <m:sSubPr>
+                        <m:ctrlPr>
+                          <a:rPr lang="en-US" sz="1800" b="0" i="1" u="none" strike="noStrike" smtClean="0">
+                            <a:solidFill>
+                              <a:srgbClr val="1F2937"/>
+                            </a:solidFill>
+                            <a:effectLst/>
+                            <a:uFillTx/>
+                            <a:latin typeface="Cambria Math" panose="02040503050406030204" pitchFamily="18" charset="0"/>
+                            <a:ea typeface="Cambria Math" panose="02040503050406030204" pitchFamily="18" charset="0"/>
+                          </a:rPr>
+                        </m:ctrlPr>
+                      </m:sSubPr>
+                      <m:e>
+                        <m:r>
+                          <a:rPr lang="en-US" sz="1800" b="0" i="1" u="none" strike="noStrike" smtClean="0">
+                            <a:solidFill>
+                              <a:srgbClr val="1F2937"/>
+                            </a:solidFill>
+                            <a:effectLst/>
+                            <a:uFillTx/>
+                            <a:latin typeface="Cambria Math" panose="02040503050406030204" pitchFamily="18" charset="0"/>
+                            <a:ea typeface="Cambria Math" panose="02040503050406030204" pitchFamily="18" charset="0"/>
+                          </a:rPr>
+                          <m:t>𝜔</m:t>
+                        </m:r>
+                      </m:e>
+                      <m:sub>
+                        <m:r>
+                          <a:rPr lang="en-US" sz="1800" b="0" i="1" u="none" strike="noStrike" smtClean="0">
+                            <a:solidFill>
+                              <a:srgbClr val="1F2937"/>
+                            </a:solidFill>
+                            <a:effectLst/>
+                            <a:uFillTx/>
+                            <a:latin typeface="Cambria Math" panose="02040503050406030204" pitchFamily="18" charset="0"/>
+                            <a:ea typeface="Cambria Math" panose="02040503050406030204" pitchFamily="18" charset="0"/>
+                          </a:rPr>
+                          <m:t>0</m:t>
+                        </m:r>
+                      </m:sub>
+                    </m:sSub>
+                  </m:oMath>
+                </a14:m>
+                <a:r>
+                  <a:rPr lang="en-US" sz="1800" b="0" u="none" strike="noStrike" dirty="0">
+                    <a:solidFill>
+                      <a:srgbClr val="1F2937"/>
+                    </a:solidFill>
+                    <a:effectLst/>
+                    <a:uFillTx/>
+                    <a:latin typeface="Aptos"/>
+                  </a:rPr>
+                  <a:t>?</a:t>
+                </a:r>
+                <a:endParaRPr lang="en-US" sz="1800" b="0" u="none" strike="noStrike" dirty="0">
+                  <a:solidFill>
+                    <a:srgbClr val="000000"/>
+                  </a:solidFill>
+                  <a:effectLst/>
+                  <a:uFillTx/>
+                  <a:latin typeface="Arial"/>
+                </a:endParaRPr>
+              </a:p>
+              <a:p>
+                <a:pPr marL="228600" indent="-228600" defTabSz="914400">
+                  <a:lnSpc>
+                    <a:spcPct val="100000"/>
+                  </a:lnSpc>
+                  <a:buClr>
+                    <a:srgbClr val="1F2937"/>
+                  </a:buClr>
+                  <a:buFont typeface="Symbol" charset="2"/>
+                  <a:buChar char=""/>
+                </a:pPr>
+                <a:r>
+                  <a:rPr lang="en-US" sz="1800" b="0" u="none" strike="noStrike" dirty="0">
+                    <a:solidFill>
+                      <a:srgbClr val="1F2937"/>
+                    </a:solidFill>
+                    <a:effectLst/>
+                    <a:uFillTx/>
+                    <a:latin typeface="Aptos"/>
+                  </a:rPr>
+                  <a:t>Good answer: the denominator vector becomes much shorter, so magnitude increases sharply and the phase changes more rapidly.</a:t>
+                </a:r>
+                <a:endParaRPr lang="en-US" sz="1800" b="0" u="none" strike="noStrike" dirty="0">
+                  <a:solidFill>
+                    <a:srgbClr val="000000"/>
+                  </a:solidFill>
+                  <a:effectLst/>
+                  <a:uFillTx/>
+                  <a:latin typeface="Arial"/>
+                </a:endParaRPr>
+              </a:p>
+              <a:p>
+                <a:pPr marL="228600" indent="-228600" defTabSz="914400">
+                  <a:lnSpc>
+                    <a:spcPct val="100000"/>
+                  </a:lnSpc>
+                  <a:buClr>
+                    <a:srgbClr val="1F2937"/>
+                  </a:buClr>
+                  <a:buFont typeface="Symbol" charset="2"/>
+                  <a:buChar char=""/>
+                </a:pPr>
+                <a:r>
+                  <a:rPr lang="en-US" sz="1800" b="0" u="none" strike="noStrike" dirty="0">
+                    <a:solidFill>
+                      <a:srgbClr val="1F2937"/>
+                    </a:solidFill>
+                    <a:effectLst/>
+                    <a:uFillTx/>
+                    <a:latin typeface="Aptos"/>
+                  </a:rPr>
+                  <a:t>Graduate-level addition: the pole also produces a more concentrated group-delay contribution near its angle.</a:t>
+                </a:r>
+                <a:endParaRPr lang="en-US" sz="1800" b="0" u="none" strike="noStrike" dirty="0">
+                  <a:solidFill>
+                    <a:srgbClr val="000000"/>
+                  </a:solidFill>
+                  <a:effectLst/>
+                  <a:uFillTx/>
+                  <a:latin typeface="Arial"/>
+                </a:endParaRPr>
+              </a:p>
+            </p:txBody>
+          </p:sp>
+        </mc:Choice>
+        <mc:Fallback>
+          <p:sp>
+            <p:nvSpPr>
+              <p:cNvPr id="62" name="Text 5"/>
+              <p:cNvSpPr>
+                <a:spLocks noRot="1" noChangeAspect="1" noMove="1" noResize="1" noEditPoints="1" noAdjustHandles="1" noChangeArrowheads="1" noChangeShapeType="1" noTextEdit="1"/>
+              </p:cNvSpPr>
+              <p:nvPr/>
+            </p:nvSpPr>
+            <p:spPr>
+              <a:xfrm>
+                <a:off x="777240" y="1417320"/>
+                <a:ext cx="10515240" cy="3931560"/>
+              </a:xfrm>
+              <a:prstGeom prst="rect">
+                <a:avLst/>
+              </a:prstGeom>
+              <a:blipFill>
+                <a:blip r:embed="rId3"/>
+                <a:stretch>
+                  <a:fillRect l="-1392" t="-2329"/>
+                </a:stretch>
+              </a:blipFill>
+              <a:ln w="0">
+                <a:noFill/>
+              </a:ln>
+            </p:spPr>
+            <p:txBody>
+              <a:bodyPr/>
+              <a:lstStyle/>
+              <a:p>
+                <a:r>
+                  <a:rPr lang="en-US">
+                    <a:noFill/>
+                  </a:rPr>
+                  <a:t> </a:t>
+                </a:r>
+              </a:p>
+            </p:txBody>
+          </p:sp>
+        </mc:Fallback>
+      </mc:AlternateContent>
     </p:spTree>
   </p:cSld>
   <p:clrMapOvr>
@@ -17849,150 +19997,638 @@
           </a:p>
         </p:txBody>
       </p:sp>
-      <p:sp>
-        <p:nvSpPr>
-          <p:cNvPr id="68" name="Text 5"/>
-          <p:cNvSpPr/>
-          <p:nvPr/>
-        </p:nvSpPr>
-        <p:spPr>
-          <a:xfrm>
-            <a:off x="685800" y="1371600"/>
-            <a:ext cx="5303160" cy="731160"/>
-          </a:xfrm>
-          <a:prstGeom prst="rect">
-            <a:avLst/>
-          </a:prstGeom>
-          <a:solidFill>
-            <a:srgbClr val="F4F7FB"/>
-          </a:solidFill>
-          <a:ln w="12700">
-            <a:solidFill>
-              <a:srgbClr val="D7E0EA"/>
-            </a:solidFill>
-            <a:round/>
-          </a:ln>
-        </p:spPr>
-        <p:style>
-          <a:lnRef idx="0">
-            <a:scrgbClr r="0" g="0" b="0"/>
-          </a:lnRef>
-          <a:fillRef idx="0">
-            <a:scrgbClr r="0" g="0" b="0"/>
-          </a:fillRef>
-          <a:effectRef idx="0">
-            <a:scrgbClr r="0" g="0" b="0"/>
-          </a:effectRef>
-          <a:fontRef idx="minor"/>
-        </p:style>
-        <p:txBody>
-          <a:bodyPr lIns="360" tIns="360" rIns="360" bIns="360" anchor="ctr">
-            <a:noAutofit/>
-          </a:bodyPr>
-          <a:lstStyle/>
-          <a:p>
-            <a:pPr algn="ctr" defTabSz="914400">
-              <a:lnSpc>
-                <a:spcPct val="100000"/>
-              </a:lnSpc>
-              <a:tabLst>
-                <a:tab pos="0" algn="l"/>
-              </a:tabLst>
-            </a:pPr>
-            <a:r>
-              <a:rPr lang="en-US" sz="2100" b="1" u="none" strike="noStrike">
-                <a:solidFill>
-                  <a:srgbClr val="17365D"/>
-                </a:solidFill>
-                <a:effectLst/>
-                <a:uFillTx/>
-                <a:latin typeface="Aptos"/>
-              </a:rPr>
-              <a:t>$$\tau_p(\omega)=-\frac{\angle H(e^{j\omega})}{\omega}$$</a:t>
-            </a:r>
-            <a:endParaRPr lang="en-US" sz="2100" b="0" u="none" strike="noStrike">
-              <a:solidFill>
-                <a:srgbClr val="000000"/>
-              </a:solidFill>
-              <a:effectLst/>
-              <a:uFillTx/>
-              <a:latin typeface="Arial"/>
-            </a:endParaRPr>
-          </a:p>
-        </p:txBody>
-      </p:sp>
-      <p:sp>
-        <p:nvSpPr>
-          <p:cNvPr id="69" name="Text 6"/>
-          <p:cNvSpPr/>
-          <p:nvPr/>
-        </p:nvSpPr>
-        <p:spPr>
-          <a:xfrm>
-            <a:off x="6172200" y="1371600"/>
-            <a:ext cx="5303160" cy="731160"/>
-          </a:xfrm>
-          <a:prstGeom prst="rect">
-            <a:avLst/>
-          </a:prstGeom>
-          <a:solidFill>
-            <a:srgbClr val="F4F7FB"/>
-          </a:solidFill>
-          <a:ln w="12700">
-            <a:solidFill>
-              <a:srgbClr val="D7E0EA"/>
-            </a:solidFill>
-            <a:round/>
-          </a:ln>
-        </p:spPr>
-        <p:style>
-          <a:lnRef idx="0">
-            <a:scrgbClr r="0" g="0" b="0"/>
-          </a:lnRef>
-          <a:fillRef idx="0">
-            <a:scrgbClr r="0" g="0" b="0"/>
-          </a:fillRef>
-          <a:effectRef idx="0">
-            <a:scrgbClr r="0" g="0" b="0"/>
-          </a:effectRef>
-          <a:fontRef idx="minor"/>
-        </p:style>
-        <p:txBody>
-          <a:bodyPr lIns="360" tIns="360" rIns="360" bIns="360" anchor="ctr">
-            <a:noAutofit/>
-          </a:bodyPr>
-          <a:lstStyle/>
-          <a:p>
-            <a:pPr algn="ctr" defTabSz="914400">
-              <a:lnSpc>
-                <a:spcPct val="100000"/>
-              </a:lnSpc>
-              <a:tabLst>
-                <a:tab pos="0" algn="l"/>
-              </a:tabLst>
-            </a:pPr>
-            <a:r>
-              <a:rPr lang="en-US" sz="2100" b="1" u="none" strike="noStrike">
-                <a:solidFill>
-                  <a:srgbClr val="17365D"/>
-                </a:solidFill>
-                <a:effectLst/>
-                <a:uFillTx/>
-                <a:latin typeface="Aptos"/>
-              </a:rPr>
-              <a:t>$$\tau_g(\omega)=-\frac{d}{d\omega}\angle H(e^{j\omega})$$</a:t>
-            </a:r>
-            <a:endParaRPr lang="en-US" sz="2100" b="0" u="none" strike="noStrike">
-              <a:solidFill>
-                <a:srgbClr val="000000"/>
-              </a:solidFill>
-              <a:effectLst/>
-              <a:uFillTx/>
-              <a:latin typeface="Arial"/>
-            </a:endParaRPr>
-          </a:p>
-        </p:txBody>
-      </p:sp>
+      <mc:AlternateContent xmlns:mc="http://schemas.openxmlformats.org/markup-compatibility/2006">
+        <mc:Choice xmlns:a14="http://schemas.microsoft.com/office/drawing/2010/main" Requires="a14">
+          <p:sp>
+            <p:nvSpPr>
+              <p:cNvPr id="68" name="Text 5"/>
+              <p:cNvSpPr/>
+              <p:nvPr/>
+            </p:nvSpPr>
+            <p:spPr>
+              <a:xfrm>
+                <a:off x="685800" y="1281223"/>
+                <a:ext cx="5303160" cy="924673"/>
+              </a:xfrm>
+              <a:prstGeom prst="rect">
+                <a:avLst/>
+              </a:prstGeom>
+              <a:solidFill>
+                <a:srgbClr val="F4F7FB"/>
+              </a:solidFill>
+              <a:ln w="12700">
+                <a:solidFill>
+                  <a:srgbClr val="D7E0EA"/>
+                </a:solidFill>
+                <a:round/>
+              </a:ln>
+            </p:spPr>
+            <p:style>
+              <a:lnRef idx="0">
+                <a:scrgbClr r="0" g="0" b="0"/>
+              </a:lnRef>
+              <a:fillRef idx="0">
+                <a:scrgbClr r="0" g="0" b="0"/>
+              </a:fillRef>
+              <a:effectRef idx="0">
+                <a:scrgbClr r="0" g="0" b="0"/>
+              </a:effectRef>
+              <a:fontRef idx="minor"/>
+            </p:style>
+            <p:txBody>
+              <a:bodyPr lIns="360" tIns="360" rIns="360" bIns="360" anchor="ctr">
+                <a:noAutofit/>
+              </a:bodyPr>
+              <a:lstStyle/>
+              <a:p>
+                <a:pPr algn="ctr" defTabSz="914400">
+                  <a:lnSpc>
+                    <a:spcPct val="100000"/>
+                  </a:lnSpc>
+                  <a:tabLst>
+                    <a:tab pos="0" algn="l"/>
+                  </a:tabLst>
+                </a:pPr>
+                <a14:m>
+                  <m:oMathPara xmlns:m="http://schemas.openxmlformats.org/officeDocument/2006/math">
+                    <m:oMath>
+                      <m:sSub>
+                        <m:sSubPr>
+                          <m:ctrlPr>
+                            <a:rPr lang="en-US" sz="2100" b="0" i="1" u="none" strike="noStrike" smtClean="0">
+                              <a:solidFill>
+                                <a:srgbClr val="000000"/>
+                              </a:solidFill>
+                              <a:effectLst/>
+                              <a:uFillTx/>
+                              <a:latin typeface="Cambria Math" panose="02040503050406030204" pitchFamily="18" charset="0"/>
+                              <a:ea typeface="Cambria Math" panose="02040503050406030204" pitchFamily="18" charset="0"/>
+                            </a:rPr>
+                          </m:ctrlPr>
+                        </m:sSubPr>
+                        <m:e>
+                          <m:r>
+                            <a:rPr lang="en-US" sz="2100" b="0" i="1" u="none" strike="noStrike" smtClean="0">
+                              <a:solidFill>
+                                <a:srgbClr val="000000"/>
+                              </a:solidFill>
+                              <a:effectLst/>
+                              <a:uFillTx/>
+                              <a:latin typeface="Cambria Math" panose="02040503050406030204" pitchFamily="18" charset="0"/>
+                              <a:ea typeface="Cambria Math" panose="02040503050406030204" pitchFamily="18" charset="0"/>
+                            </a:rPr>
+                            <m:t>𝜏</m:t>
+                          </m:r>
+                        </m:e>
+                        <m:sub>
+                          <m:r>
+                            <a:rPr lang="en-US" sz="2100" b="0" i="1" u="none" strike="noStrike" smtClean="0">
+                              <a:solidFill>
+                                <a:srgbClr val="000000"/>
+                              </a:solidFill>
+                              <a:effectLst/>
+                              <a:uFillTx/>
+                              <a:latin typeface="Cambria Math" panose="02040503050406030204" pitchFamily="18" charset="0"/>
+                              <a:ea typeface="Cambria Math" panose="02040503050406030204" pitchFamily="18" charset="0"/>
+                            </a:rPr>
+                            <m:t>𝑝</m:t>
+                          </m:r>
+                        </m:sub>
+                      </m:sSub>
+                      <m:r>
+                        <a:rPr lang="en-US" sz="2100" b="0" i="1" u="none" strike="noStrike" smtClean="0">
+                          <a:solidFill>
+                            <a:srgbClr val="000000"/>
+                          </a:solidFill>
+                          <a:effectLst/>
+                          <a:uFillTx/>
+                          <a:latin typeface="Cambria Math" panose="02040503050406030204" pitchFamily="18" charset="0"/>
+                          <a:ea typeface="Cambria Math" panose="02040503050406030204" pitchFamily="18" charset="0"/>
+                        </a:rPr>
+                        <m:t>=−</m:t>
+                      </m:r>
+                      <m:f>
+                        <m:fPr>
+                          <m:ctrlPr>
+                            <a:rPr lang="en-US" sz="2100" b="0" i="1" u="none" strike="noStrike" smtClean="0">
+                              <a:solidFill>
+                                <a:srgbClr val="000000"/>
+                              </a:solidFill>
+                              <a:effectLst/>
+                              <a:uFillTx/>
+                              <a:latin typeface="Cambria Math" panose="02040503050406030204" pitchFamily="18" charset="0"/>
+                              <a:ea typeface="Cambria Math" panose="02040503050406030204" pitchFamily="18" charset="0"/>
+                            </a:rPr>
+                          </m:ctrlPr>
+                        </m:fPr>
+                        <m:num>
+                          <m:r>
+                            <a:rPr lang="en-US" sz="2100" b="0" i="1" u="none" strike="noStrike" smtClean="0">
+                              <a:solidFill>
+                                <a:srgbClr val="000000"/>
+                              </a:solidFill>
+                              <a:effectLst/>
+                              <a:uFillTx/>
+                              <a:latin typeface="Cambria Math" panose="02040503050406030204" pitchFamily="18" charset="0"/>
+                              <a:ea typeface="Cambria Math" panose="02040503050406030204" pitchFamily="18" charset="0"/>
+                            </a:rPr>
+                            <m:t>∠</m:t>
+                          </m:r>
+                          <m:r>
+                            <a:rPr lang="en-US" sz="2100" b="0" i="1" u="none" strike="noStrike" smtClean="0">
+                              <a:solidFill>
+                                <a:srgbClr val="000000"/>
+                              </a:solidFill>
+                              <a:effectLst/>
+                              <a:uFillTx/>
+                              <a:latin typeface="Cambria Math" panose="02040503050406030204" pitchFamily="18" charset="0"/>
+                              <a:ea typeface="Cambria Math" panose="02040503050406030204" pitchFamily="18" charset="0"/>
+                            </a:rPr>
+                            <m:t>𝐻</m:t>
+                          </m:r>
+                          <m:r>
+                            <a:rPr lang="en-US" sz="2100" b="0" i="1" u="none" strike="noStrike" smtClean="0">
+                              <a:solidFill>
+                                <a:srgbClr val="000000"/>
+                              </a:solidFill>
+                              <a:effectLst/>
+                              <a:uFillTx/>
+                              <a:latin typeface="Cambria Math" panose="02040503050406030204" pitchFamily="18" charset="0"/>
+                              <a:ea typeface="Cambria Math" panose="02040503050406030204" pitchFamily="18" charset="0"/>
+                            </a:rPr>
+                            <m:t>(</m:t>
+                          </m:r>
+                          <m:sSup>
+                            <m:sSupPr>
+                              <m:ctrlPr>
+                                <a:rPr lang="en-US" sz="2100" b="0" i="1" u="none" strike="noStrike" smtClean="0">
+                                  <a:solidFill>
+                                    <a:srgbClr val="000000"/>
+                                  </a:solidFill>
+                                  <a:effectLst/>
+                                  <a:uFillTx/>
+                                  <a:latin typeface="Cambria Math" panose="02040503050406030204" pitchFamily="18" charset="0"/>
+                                  <a:ea typeface="Cambria Math" panose="02040503050406030204" pitchFamily="18" charset="0"/>
+                                </a:rPr>
+                              </m:ctrlPr>
+                            </m:sSupPr>
+                            <m:e>
+                              <m:r>
+                                <a:rPr lang="en-US" sz="2100" b="0" i="1" u="none" strike="noStrike" smtClean="0">
+                                  <a:solidFill>
+                                    <a:srgbClr val="000000"/>
+                                  </a:solidFill>
+                                  <a:effectLst/>
+                                  <a:uFillTx/>
+                                  <a:latin typeface="Cambria Math" panose="02040503050406030204" pitchFamily="18" charset="0"/>
+                                  <a:ea typeface="Cambria Math" panose="02040503050406030204" pitchFamily="18" charset="0"/>
+                                </a:rPr>
+                                <m:t>𝑒</m:t>
+                              </m:r>
+                            </m:e>
+                            <m:sup>
+                              <m:r>
+                                <a:rPr lang="en-US" sz="2100" b="0" i="1" u="none" strike="noStrike" smtClean="0">
+                                  <a:solidFill>
+                                    <a:srgbClr val="000000"/>
+                                  </a:solidFill>
+                                  <a:effectLst/>
+                                  <a:uFillTx/>
+                                  <a:latin typeface="Cambria Math" panose="02040503050406030204" pitchFamily="18" charset="0"/>
+                                  <a:ea typeface="Cambria Math" panose="02040503050406030204" pitchFamily="18" charset="0"/>
+                                </a:rPr>
+                                <m:t>𝑗</m:t>
+                              </m:r>
+                              <m:r>
+                                <a:rPr lang="en-US" sz="2100" b="0" i="1" u="none" strike="noStrike" smtClean="0">
+                                  <a:solidFill>
+                                    <a:srgbClr val="000000"/>
+                                  </a:solidFill>
+                                  <a:effectLst/>
+                                  <a:uFillTx/>
+                                  <a:latin typeface="Cambria Math" panose="02040503050406030204" pitchFamily="18" charset="0"/>
+                                  <a:ea typeface="Cambria Math" panose="02040503050406030204" pitchFamily="18" charset="0"/>
+                                </a:rPr>
+                                <m:t>𝜔</m:t>
+                              </m:r>
+                            </m:sup>
+                          </m:sSup>
+                          <m:r>
+                            <a:rPr lang="en-US" sz="2100" b="0" i="1" u="none" strike="noStrike" smtClean="0">
+                              <a:solidFill>
+                                <a:srgbClr val="000000"/>
+                              </a:solidFill>
+                              <a:effectLst/>
+                              <a:uFillTx/>
+                              <a:latin typeface="Cambria Math" panose="02040503050406030204" pitchFamily="18" charset="0"/>
+                              <a:ea typeface="Cambria Math" panose="02040503050406030204" pitchFamily="18" charset="0"/>
+                            </a:rPr>
+                            <m:t>)</m:t>
+                          </m:r>
+                        </m:num>
+                        <m:den>
+                          <m:r>
+                            <a:rPr lang="en-US" sz="2100" b="0" i="1" u="none" strike="noStrike" smtClean="0">
+                              <a:solidFill>
+                                <a:srgbClr val="000000"/>
+                              </a:solidFill>
+                              <a:effectLst/>
+                              <a:uFillTx/>
+                              <a:latin typeface="Cambria Math" panose="02040503050406030204" pitchFamily="18" charset="0"/>
+                              <a:ea typeface="Cambria Math" panose="02040503050406030204" pitchFamily="18" charset="0"/>
+                            </a:rPr>
+                            <m:t>𝜔</m:t>
+                          </m:r>
+                        </m:den>
+                      </m:f>
+                    </m:oMath>
+                  </m:oMathPara>
+                </a14:m>
+                <a:endParaRPr lang="en-US" sz="2100" b="0" u="none" strike="noStrike" dirty="0">
+                  <a:solidFill>
+                    <a:srgbClr val="000000"/>
+                  </a:solidFill>
+                  <a:effectLst/>
+                  <a:uFillTx/>
+                  <a:latin typeface="Arial"/>
+                </a:endParaRPr>
+              </a:p>
+            </p:txBody>
+          </p:sp>
+        </mc:Choice>
+        <mc:Fallback>
+          <p:sp>
+            <p:nvSpPr>
+              <p:cNvPr id="68" name="Text 5"/>
+              <p:cNvSpPr>
+                <a:spLocks noRot="1" noChangeAspect="1" noMove="1" noResize="1" noEditPoints="1" noAdjustHandles="1" noChangeArrowheads="1" noChangeShapeType="1" noTextEdit="1"/>
+              </p:cNvSpPr>
+              <p:nvPr/>
+            </p:nvSpPr>
+            <p:spPr>
+              <a:xfrm>
+                <a:off x="685800" y="1281223"/>
+                <a:ext cx="5303160" cy="924673"/>
+              </a:xfrm>
+              <a:prstGeom prst="rect">
+                <a:avLst/>
+              </a:prstGeom>
+              <a:blipFill>
+                <a:blip r:embed="rId3"/>
+                <a:stretch>
+                  <a:fillRect/>
+                </a:stretch>
+              </a:blipFill>
+              <a:ln w="12700">
+                <a:solidFill>
+                  <a:srgbClr val="D7E0EA"/>
+                </a:solidFill>
+                <a:round/>
+              </a:ln>
+            </p:spPr>
+            <p:txBody>
+              <a:bodyPr/>
+              <a:lstStyle/>
+              <a:p>
+                <a:r>
+                  <a:rPr lang="en-US">
+                    <a:noFill/>
+                  </a:rPr>
+                  <a:t> </a:t>
+                </a:r>
+              </a:p>
+            </p:txBody>
+          </p:sp>
+        </mc:Fallback>
+      </mc:AlternateContent>
+      <mc:AlternateContent xmlns:mc="http://schemas.openxmlformats.org/markup-compatibility/2006">
+        <mc:Choice xmlns:a14="http://schemas.microsoft.com/office/drawing/2010/main" Requires="a14">
+          <p:sp>
+            <p:nvSpPr>
+              <p:cNvPr id="69" name="Text 6"/>
+              <p:cNvSpPr/>
+              <p:nvPr/>
+            </p:nvSpPr>
+            <p:spPr>
+              <a:xfrm>
+                <a:off x="6172200" y="1279423"/>
+                <a:ext cx="5303160" cy="924673"/>
+              </a:xfrm>
+              <a:prstGeom prst="rect">
+                <a:avLst/>
+              </a:prstGeom>
+              <a:solidFill>
+                <a:srgbClr val="F4F7FB"/>
+              </a:solidFill>
+              <a:ln w="12700">
+                <a:solidFill>
+                  <a:srgbClr val="D7E0EA"/>
+                </a:solidFill>
+                <a:round/>
+              </a:ln>
+            </p:spPr>
+            <p:style>
+              <a:lnRef idx="0">
+                <a:scrgbClr r="0" g="0" b="0"/>
+              </a:lnRef>
+              <a:fillRef idx="0">
+                <a:scrgbClr r="0" g="0" b="0"/>
+              </a:fillRef>
+              <a:effectRef idx="0">
+                <a:scrgbClr r="0" g="0" b="0"/>
+              </a:effectRef>
+              <a:fontRef idx="minor"/>
+            </p:style>
+            <p:txBody>
+              <a:bodyPr lIns="360" tIns="360" rIns="360" bIns="360" anchor="ctr">
+                <a:noAutofit/>
+              </a:bodyPr>
+              <a:lstStyle/>
+              <a:p>
+                <a:pPr algn="ctr" defTabSz="914400">
+                  <a:lnSpc>
+                    <a:spcPct val="100000"/>
+                  </a:lnSpc>
+                  <a:tabLst>
+                    <a:tab pos="0" algn="l"/>
+                  </a:tabLst>
+                </a:pPr>
+                <a14:m>
+                  <m:oMathPara xmlns:m="http://schemas.openxmlformats.org/officeDocument/2006/math">
+                    <m:oMath>
+                      <m:sSub>
+                        <m:sSubPr>
+                          <m:ctrlPr>
+                            <a:rPr lang="en-US" sz="2100" b="0" i="1" u="none" strike="noStrike" smtClean="0">
+                              <a:solidFill>
+                                <a:srgbClr val="000000"/>
+                              </a:solidFill>
+                              <a:effectLst/>
+                              <a:uFillTx/>
+                              <a:latin typeface="Cambria Math" panose="02040503050406030204" pitchFamily="18" charset="0"/>
+                              <a:ea typeface="Cambria Math" panose="02040503050406030204" pitchFamily="18" charset="0"/>
+                            </a:rPr>
+                          </m:ctrlPr>
+                        </m:sSubPr>
+                        <m:e>
+                          <m:r>
+                            <a:rPr lang="en-US" sz="2100" b="0" i="1" u="none" strike="noStrike" smtClean="0">
+                              <a:solidFill>
+                                <a:srgbClr val="000000"/>
+                              </a:solidFill>
+                              <a:effectLst/>
+                              <a:uFillTx/>
+                              <a:latin typeface="Cambria Math" panose="02040503050406030204" pitchFamily="18" charset="0"/>
+                              <a:ea typeface="Cambria Math" panose="02040503050406030204" pitchFamily="18" charset="0"/>
+                            </a:rPr>
+                            <m:t>𝜏</m:t>
+                          </m:r>
+                        </m:e>
+                        <m:sub>
+                          <m:r>
+                            <a:rPr lang="en-US" sz="2100" b="0" i="1" u="none" strike="noStrike" smtClean="0">
+                              <a:solidFill>
+                                <a:srgbClr val="000000"/>
+                              </a:solidFill>
+                              <a:effectLst/>
+                              <a:uFillTx/>
+                              <a:latin typeface="Cambria Math" panose="02040503050406030204" pitchFamily="18" charset="0"/>
+                              <a:ea typeface="Cambria Math" panose="02040503050406030204" pitchFamily="18" charset="0"/>
+                            </a:rPr>
+                            <m:t>𝑔</m:t>
+                          </m:r>
+                        </m:sub>
+                      </m:sSub>
+                      <m:r>
+                        <a:rPr lang="en-US" sz="2100" b="0" i="1" u="none" strike="noStrike" smtClean="0">
+                          <a:solidFill>
+                            <a:srgbClr val="000000"/>
+                          </a:solidFill>
+                          <a:effectLst/>
+                          <a:uFillTx/>
+                          <a:latin typeface="Cambria Math" panose="02040503050406030204" pitchFamily="18" charset="0"/>
+                          <a:ea typeface="Cambria Math" panose="02040503050406030204" pitchFamily="18" charset="0"/>
+                        </a:rPr>
+                        <m:t>=−</m:t>
+                      </m:r>
+                      <m:f>
+                        <m:fPr>
+                          <m:ctrlPr>
+                            <a:rPr lang="en-US" sz="2100" b="0" i="1" u="none" strike="noStrike" smtClean="0">
+                              <a:solidFill>
+                                <a:srgbClr val="000000"/>
+                              </a:solidFill>
+                              <a:effectLst/>
+                              <a:uFillTx/>
+                              <a:latin typeface="Cambria Math" panose="02040503050406030204" pitchFamily="18" charset="0"/>
+                              <a:ea typeface="Cambria Math" panose="02040503050406030204" pitchFamily="18" charset="0"/>
+                            </a:rPr>
+                          </m:ctrlPr>
+                        </m:fPr>
+                        <m:num>
+                          <m:r>
+                            <a:rPr lang="en-US" sz="2100" b="0" i="1" u="none" strike="noStrike" smtClean="0">
+                              <a:solidFill>
+                                <a:srgbClr val="000000"/>
+                              </a:solidFill>
+                              <a:effectLst/>
+                              <a:uFillTx/>
+                              <a:latin typeface="Cambria Math" panose="02040503050406030204" pitchFamily="18" charset="0"/>
+                              <a:ea typeface="Cambria Math" panose="02040503050406030204" pitchFamily="18" charset="0"/>
+                            </a:rPr>
+                            <m:t>𝑑</m:t>
+                          </m:r>
+                        </m:num>
+                        <m:den>
+                          <m:r>
+                            <a:rPr lang="en-US" sz="2100" b="0" i="1" u="none" strike="noStrike" smtClean="0">
+                              <a:solidFill>
+                                <a:srgbClr val="000000"/>
+                              </a:solidFill>
+                              <a:effectLst/>
+                              <a:uFillTx/>
+                              <a:latin typeface="Cambria Math" panose="02040503050406030204" pitchFamily="18" charset="0"/>
+                              <a:ea typeface="Cambria Math" panose="02040503050406030204" pitchFamily="18" charset="0"/>
+                            </a:rPr>
+                            <m:t>𝑑</m:t>
+                          </m:r>
+                          <m:r>
+                            <a:rPr lang="en-US" sz="2100" b="0" i="1" u="none" strike="noStrike" smtClean="0">
+                              <a:solidFill>
+                                <a:srgbClr val="000000"/>
+                              </a:solidFill>
+                              <a:effectLst/>
+                              <a:uFillTx/>
+                              <a:latin typeface="Cambria Math" panose="02040503050406030204" pitchFamily="18" charset="0"/>
+                              <a:ea typeface="Cambria Math" panose="02040503050406030204" pitchFamily="18" charset="0"/>
+                            </a:rPr>
+                            <m:t>𝜔</m:t>
+                          </m:r>
+                        </m:den>
+                      </m:f>
+                      <m:r>
+                        <a:rPr lang="en-US" sz="2100" b="0" i="1" u="none" strike="noStrike" smtClean="0">
+                          <a:solidFill>
+                            <a:srgbClr val="000000"/>
+                          </a:solidFill>
+                          <a:effectLst/>
+                          <a:uFillTx/>
+                          <a:latin typeface="Cambria Math" panose="02040503050406030204" pitchFamily="18" charset="0"/>
+                          <a:ea typeface="Cambria Math" panose="02040503050406030204" pitchFamily="18" charset="0"/>
+                        </a:rPr>
+                        <m:t>∠</m:t>
+                      </m:r>
+                      <m:r>
+                        <a:rPr lang="en-US" sz="2100" b="0" i="1" u="none" strike="noStrike" smtClean="0">
+                          <a:solidFill>
+                            <a:srgbClr val="000000"/>
+                          </a:solidFill>
+                          <a:effectLst/>
+                          <a:uFillTx/>
+                          <a:latin typeface="Cambria Math" panose="02040503050406030204" pitchFamily="18" charset="0"/>
+                          <a:ea typeface="Cambria Math" panose="02040503050406030204" pitchFamily="18" charset="0"/>
+                        </a:rPr>
+                        <m:t>𝐻</m:t>
+                      </m:r>
+                      <m:r>
+                        <a:rPr lang="en-US" sz="2100" b="0" i="1" u="none" strike="noStrike" smtClean="0">
+                          <a:solidFill>
+                            <a:srgbClr val="000000"/>
+                          </a:solidFill>
+                          <a:effectLst/>
+                          <a:uFillTx/>
+                          <a:latin typeface="Cambria Math" panose="02040503050406030204" pitchFamily="18" charset="0"/>
+                          <a:ea typeface="Cambria Math" panose="02040503050406030204" pitchFamily="18" charset="0"/>
+                        </a:rPr>
+                        <m:t>(</m:t>
+                      </m:r>
+                      <m:sSup>
+                        <m:sSupPr>
+                          <m:ctrlPr>
+                            <a:rPr lang="en-US" sz="2100" b="0" i="1" u="none" strike="noStrike" smtClean="0">
+                              <a:solidFill>
+                                <a:srgbClr val="000000"/>
+                              </a:solidFill>
+                              <a:effectLst/>
+                              <a:uFillTx/>
+                              <a:latin typeface="Cambria Math" panose="02040503050406030204" pitchFamily="18" charset="0"/>
+                              <a:ea typeface="Cambria Math" panose="02040503050406030204" pitchFamily="18" charset="0"/>
+                            </a:rPr>
+                          </m:ctrlPr>
+                        </m:sSupPr>
+                        <m:e>
+                          <m:r>
+                            <a:rPr lang="en-US" sz="2100" b="0" i="1" u="none" strike="noStrike" smtClean="0">
+                              <a:solidFill>
+                                <a:srgbClr val="000000"/>
+                              </a:solidFill>
+                              <a:effectLst/>
+                              <a:uFillTx/>
+                              <a:latin typeface="Cambria Math" panose="02040503050406030204" pitchFamily="18" charset="0"/>
+                              <a:ea typeface="Cambria Math" panose="02040503050406030204" pitchFamily="18" charset="0"/>
+                            </a:rPr>
+                            <m:t>𝑒</m:t>
+                          </m:r>
+                        </m:e>
+                        <m:sup>
+                          <m:r>
+                            <a:rPr lang="en-US" sz="2100" b="0" i="1" u="none" strike="noStrike" smtClean="0">
+                              <a:solidFill>
+                                <a:srgbClr val="000000"/>
+                              </a:solidFill>
+                              <a:effectLst/>
+                              <a:uFillTx/>
+                              <a:latin typeface="Cambria Math" panose="02040503050406030204" pitchFamily="18" charset="0"/>
+                              <a:ea typeface="Cambria Math" panose="02040503050406030204" pitchFamily="18" charset="0"/>
+                            </a:rPr>
+                            <m:t>𝑗</m:t>
+                          </m:r>
+                          <m:r>
+                            <a:rPr lang="en-US" sz="2100" b="0" i="1" u="none" strike="noStrike" smtClean="0">
+                              <a:solidFill>
+                                <a:srgbClr val="000000"/>
+                              </a:solidFill>
+                              <a:effectLst/>
+                              <a:uFillTx/>
+                              <a:latin typeface="Cambria Math" panose="02040503050406030204" pitchFamily="18" charset="0"/>
+                              <a:ea typeface="Cambria Math" panose="02040503050406030204" pitchFamily="18" charset="0"/>
+                            </a:rPr>
+                            <m:t>𝜔</m:t>
+                          </m:r>
+                        </m:sup>
+                      </m:sSup>
+                      <m:r>
+                        <a:rPr lang="en-US" sz="2100" b="0" i="1" u="none" strike="noStrike" smtClean="0">
+                          <a:solidFill>
+                            <a:srgbClr val="000000"/>
+                          </a:solidFill>
+                          <a:effectLst/>
+                          <a:uFillTx/>
+                          <a:latin typeface="Cambria Math" panose="02040503050406030204" pitchFamily="18" charset="0"/>
+                          <a:ea typeface="Cambria Math" panose="02040503050406030204" pitchFamily="18" charset="0"/>
+                        </a:rPr>
+                        <m:t>)</m:t>
+                      </m:r>
+                    </m:oMath>
+                  </m:oMathPara>
+                </a14:m>
+                <a:endParaRPr lang="en-US" sz="2100" b="0" u="none" strike="noStrike" dirty="0">
+                  <a:solidFill>
+                    <a:srgbClr val="000000"/>
+                  </a:solidFill>
+                  <a:effectLst/>
+                  <a:uFillTx/>
+                  <a:latin typeface="Arial"/>
+                </a:endParaRPr>
+              </a:p>
+            </p:txBody>
+          </p:sp>
+        </mc:Choice>
+        <mc:Fallback>
+          <p:sp>
+            <p:nvSpPr>
+              <p:cNvPr id="69" name="Text 6"/>
+              <p:cNvSpPr>
+                <a:spLocks noRot="1" noChangeAspect="1" noMove="1" noResize="1" noEditPoints="1" noAdjustHandles="1" noChangeArrowheads="1" noChangeShapeType="1" noTextEdit="1"/>
+              </p:cNvSpPr>
+              <p:nvPr/>
+            </p:nvSpPr>
+            <p:spPr>
+              <a:xfrm>
+                <a:off x="6172200" y="1279423"/>
+                <a:ext cx="5303160" cy="924673"/>
+              </a:xfrm>
+              <a:prstGeom prst="rect">
+                <a:avLst/>
+              </a:prstGeom>
+              <a:blipFill>
+                <a:blip r:embed="rId4"/>
+                <a:stretch>
+                  <a:fillRect/>
+                </a:stretch>
+              </a:blipFill>
+              <a:ln w="12700">
+                <a:solidFill>
+                  <a:srgbClr val="D7E0EA"/>
+                </a:solidFill>
+                <a:round/>
+              </a:ln>
+            </p:spPr>
+            <p:txBody>
+              <a:bodyPr/>
+              <a:lstStyle/>
+              <a:p>
+                <a:r>
+                  <a:rPr lang="en-US">
+                    <a:noFill/>
+                  </a:rPr>
+                  <a:t> </a:t>
+                </a:r>
+              </a:p>
+            </p:txBody>
+          </p:sp>
+        </mc:Fallback>
+      </mc:AlternateContent>
       <p:sp>
         <p:nvSpPr>
           <p:cNvPr id="70" name="Shape 7"/>

</xml_diff>